<commit_message>
Document the PC monitor page and refresh docs and handout
- User guide: new section 7 (PC monitor page: WiFi download, then USB),
  port names, troubleshooting and quick-reference updates
- Design reference: §6.4 PC monitor page, /monitor.html endpoint, build
  script, measured footprint, Arduino IDE notes, tests, corrections
- Handout: new page on the PC monitor page, "by Teknosofen" footer,
  layout fixes

Co-Authored-By: Claude Opus 5.5 <noreply@anthropic.com>
</commit_message>
<xml_diff>
--- a/documentation/Eaglehagen_Basic_Setup.pptx
+++ b/documentation/Eaglehagen_Basic_Setup.pptx
@@ -13,9 +13,10 @@
     <p:sldId id="261" r:id="rId7"/>
     <p:sldId id="262" r:id="rId8"/>
     <p:sldId id="263" r:id="rId9"/>
+    <p:sldId id="264" r:id="rId10"/>
   </p:sldIdLst>
   <p:notesMasterIdLst>
-    <p:notesMasterId r:id="rId10"/>
+    <p:notesMasterId r:id="rId11"/>
   </p:notesMasterIdLst>
   <p:sldSz cx="10689336" cy="7562088"/>
   <p:notesSz cx="7562088" cy="10689336"/>
@@ -1149,6 +1150,94 @@
             <a:fld id="{F7021451-1387-4CA6-816F-3879F97B5CBC}" type="slidenum">
               <a:rPr lang="en-US"/>
               <a:t>8</a:t>
+            </a:fld>
+            <a:endParaRPr lang="en-US"/>
+          </a:p>
+        </p:txBody>
+      </p:sp>
+    </p:spTree>
+    <p:extLst>
+      <p:ext uri="{BB962C8B-B14F-4D97-AF65-F5344CB8AC3E}">
+        <p14:creationId xmlns:p14="http://schemas.microsoft.com/office/powerpoint/2010/main" val="1024086991"/>
+      </p:ext>
+    </p:extLst>
+  </p:cSld>
+  <p:clrMapOvr>
+    <a:masterClrMapping/>
+  </p:clrMapOvr>
+</p:notes>
+</file>
+
+<file path=ppt/notesSlides/notesSlide9.xml><?xml version="1.0" encoding="utf-8"?>
+<p:notes xmlns:a="http://schemas.openxmlformats.org/drawingml/2006/main" xmlns:r="http://schemas.openxmlformats.org/officeDocument/2006/relationships" xmlns:p="http://schemas.openxmlformats.org/presentationml/2006/main">
+  <p:cSld>
+    <p:spTree>
+      <p:nvGrpSpPr>
+        <p:cNvPr id="1" name=""/>
+        <p:cNvGrpSpPr/>
+        <p:nvPr/>
+      </p:nvGrpSpPr>
+      <p:grpSpPr>
+        <a:xfrm>
+          <a:off x="0" y="0"/>
+          <a:ext cx="0" cy="0"/>
+          <a:chOff x="0" y="0"/>
+          <a:chExt cx="0" cy="0"/>
+        </a:xfrm>
+      </p:grpSpPr>
+      <p:sp>
+        <p:nvSpPr>
+          <p:cNvPr id="2" name="Slide Image Placeholder 1"/>
+          <p:cNvSpPr>
+            <a:spLocks noGrp="1" noRot="1" noChangeAspect="1"/>
+          </p:cNvSpPr>
+          <p:nvPr>
+            <p:ph type="sldImg"/>
+          </p:nvPr>
+        </p:nvSpPr>
+        <p:spPr/>
+      </p:sp>
+      <p:sp>
+        <p:nvSpPr>
+          <p:cNvPr id="3" name="Notes Placeholder 2"/>
+          <p:cNvSpPr>
+            <a:spLocks noGrp="1"/>
+          </p:cNvSpPr>
+          <p:nvPr>
+            <p:ph type="body" idx="1"/>
+          </p:nvPr>
+        </p:nvSpPr>
+        <p:spPr/>
+        <p:txBody>
+          <a:bodyPr/>
+          <a:lstStyle/>
+          <a:p>
+            <a:r>
+              <a:rPr lang="en-US" dirty="0"/>
+              <a:t/>
+            </a:r>
+            <a:endParaRPr lang="en-US" dirty="0"/>
+          </a:p>
+        </p:txBody>
+      </p:sp>
+      <p:sp>
+        <p:nvSpPr>
+          <p:cNvPr id="4" name="Slide Number Placeholder 3"/>
+          <p:cNvSpPr>
+            <a:spLocks noGrp="1"/>
+          </p:cNvSpPr>
+          <p:nvPr>
+            <p:ph type="sldNum" sz="quarter" idx="10"/>
+          </p:nvPr>
+        </p:nvSpPr>
+        <p:spPr/>
+        <p:txBody>
+          <a:bodyPr/>
+          <a:lstStyle/>
+          <a:p>
+            <a:fld id="{F7021451-1387-4CA6-816F-3879F97B5CBC}" type="slidenum">
+              <a:rPr lang="en-US"/>
+              <a:t>9</a:t>
             </a:fld>
             <a:endParaRPr lang="en-US"/>
           </a:p>
@@ -1626,7 +1715,7 @@
                 <a:ea typeface="Calibri" pitchFamily="34" charset="-122"/>
                 <a:cs typeface="Calibri" pitchFamily="34" charset="-120"/>
               </a:rPr>
-              <a:t>screen, web page, alarms and connection to LabVIEW.</a:t>
+              <a:t>screen, web page, alarms, LabVIEW and the PC monitor page.</a:t>
             </a:r>
             <a:endParaRPr lang="en-US" sz="1600" dirty="0"/>
           </a:p>
@@ -1673,46 +1762,7 @@
       </p:sp>
       <p:sp>
         <p:nvSpPr>
-          <p:cNvPr id="6" name="Text 4"/>
-          <p:cNvSpPr txBox="1"/>
-          <p:nvPr/>
-        </p:nvSpPr>
-        <p:spPr>
-          <a:xfrm>
-            <a:off x="548640" y="5440680"/>
-            <a:ext cx="6035040" cy="320040"/>
-          </a:xfrm>
-          <a:prstGeom prst="rect">
-            <a:avLst/>
-          </a:prstGeom>
-          <a:noFill/>
-          <a:ln/>
-        </p:spPr>
-        <p:txBody>
-          <a:bodyPr wrap="square" lIns="0" tIns="0" rIns="0" bIns="0" rtlCol="0" anchor="t"/>
-          <a:lstStyle/>
-          <a:p>
-            <a:pPr indent="0" marL="0">
-              <a:buNone/>
-            </a:pPr>
-            <a:r>
-              <a:rPr lang="en-US" sz="1400" b="1" dirty="0">
-                <a:solidFill>
-                  <a:srgbClr val="5B6770"/>
-                </a:solidFill>
-                <a:latin typeface="Calibri" pitchFamily="34" charset="0"/>
-                <a:ea typeface="Calibri" pitchFamily="34" charset="-122"/>
-                <a:cs typeface="Calibri" pitchFamily="34" charset="-120"/>
-              </a:rPr>
-              <a:t>Teknosofen</a:t>
-            </a:r>
-            <a:endParaRPr lang="en-US" sz="1400" dirty="0"/>
-          </a:p>
-        </p:txBody>
-      </p:sp>
-      <p:sp>
-        <p:nvSpPr>
-          <p:cNvPr id="7" name="Shape 5"/>
+          <p:cNvPr id="6" name="Shape 4"/>
           <p:cNvSpPr/>
           <p:nvPr/>
         </p:nvSpPr>
@@ -1739,7 +1789,7 @@
       </p:sp>
       <p:sp>
         <p:nvSpPr>
-          <p:cNvPr id="8" name="Shape 6"/>
+          <p:cNvPr id="7" name="Shape 5"/>
           <p:cNvSpPr/>
           <p:nvPr/>
         </p:nvSpPr>
@@ -1764,7 +1814,7 @@
       </p:sp>
       <p:sp>
         <p:nvSpPr>
-          <p:cNvPr id="9" name="Text 7"/>
+          <p:cNvPr id="8" name="Text 6"/>
           <p:cNvSpPr txBox="1"/>
           <p:nvPr/>
         </p:nvSpPr>
@@ -1803,7 +1853,7 @@
       </p:sp>
       <p:sp>
         <p:nvSpPr>
-          <p:cNvPr id="10" name="Shape 8"/>
+          <p:cNvPr id="9" name="Shape 7"/>
           <p:cNvSpPr/>
           <p:nvPr/>
         </p:nvSpPr>
@@ -1828,7 +1878,7 @@
       </p:sp>
       <p:sp>
         <p:nvSpPr>
-          <p:cNvPr id="11" name="Shape 9"/>
+          <p:cNvPr id="10" name="Shape 8"/>
           <p:cNvSpPr/>
           <p:nvPr/>
         </p:nvSpPr>
@@ -1853,7 +1903,7 @@
       </p:sp>
       <p:sp>
         <p:nvSpPr>
-          <p:cNvPr id="12" name="Shape 10"/>
+          <p:cNvPr id="11" name="Shape 9"/>
           <p:cNvSpPr/>
           <p:nvPr/>
         </p:nvSpPr>
@@ -1876,7 +1926,7 @@
       </p:sp>
       <p:sp>
         <p:nvSpPr>
-          <p:cNvPr id="13" name="Shape 11"/>
+          <p:cNvPr id="12" name="Shape 10"/>
           <p:cNvSpPr/>
           <p:nvPr/>
         </p:nvSpPr>
@@ -1899,7 +1949,7 @@
       </p:sp>
       <p:sp>
         <p:nvSpPr>
-          <p:cNvPr id="14" name="Shape 12"/>
+          <p:cNvPr id="13" name="Shape 11"/>
           <p:cNvSpPr/>
           <p:nvPr/>
         </p:nvSpPr>
@@ -1922,7 +1972,7 @@
       </p:sp>
       <p:sp>
         <p:nvSpPr>
-          <p:cNvPr id="15" name="Shape 13"/>
+          <p:cNvPr id="14" name="Shape 12"/>
           <p:cNvSpPr/>
           <p:nvPr/>
         </p:nvSpPr>
@@ -1945,7 +1995,7 @@
       </p:sp>
       <p:sp>
         <p:nvSpPr>
-          <p:cNvPr id="16" name="Shape 14"/>
+          <p:cNvPr id="15" name="Shape 13"/>
           <p:cNvSpPr/>
           <p:nvPr/>
         </p:nvSpPr>
@@ -1968,7 +2018,7 @@
       </p:sp>
       <p:sp>
         <p:nvSpPr>
-          <p:cNvPr id="17" name="Shape 15"/>
+          <p:cNvPr id="16" name="Shape 14"/>
           <p:cNvSpPr/>
           <p:nvPr/>
         </p:nvSpPr>
@@ -1991,7 +2041,7 @@
       </p:sp>
       <p:sp>
         <p:nvSpPr>
-          <p:cNvPr id="18" name="Shape 16"/>
+          <p:cNvPr id="17" name="Shape 15"/>
           <p:cNvSpPr/>
           <p:nvPr/>
         </p:nvSpPr>
@@ -2014,7 +2064,7 @@
       </p:sp>
       <p:sp>
         <p:nvSpPr>
-          <p:cNvPr id="19" name="Shape 17"/>
+          <p:cNvPr id="18" name="Shape 16"/>
           <p:cNvSpPr/>
           <p:nvPr/>
         </p:nvSpPr>
@@ -2037,7 +2087,7 @@
       </p:sp>
       <p:sp>
         <p:nvSpPr>
-          <p:cNvPr id="20" name="Shape 18"/>
+          <p:cNvPr id="19" name="Shape 17"/>
           <p:cNvSpPr/>
           <p:nvPr/>
         </p:nvSpPr>
@@ -2060,7 +2110,7 @@
       </p:sp>
       <p:sp>
         <p:nvSpPr>
-          <p:cNvPr id="21" name="Shape 19"/>
+          <p:cNvPr id="20" name="Shape 18"/>
           <p:cNvSpPr/>
           <p:nvPr/>
         </p:nvSpPr>
@@ -2083,7 +2133,7 @@
       </p:sp>
       <p:sp>
         <p:nvSpPr>
-          <p:cNvPr id="22" name="Shape 20"/>
+          <p:cNvPr id="21" name="Shape 19"/>
           <p:cNvSpPr/>
           <p:nvPr/>
         </p:nvSpPr>
@@ -2106,7 +2156,7 @@
       </p:sp>
       <p:sp>
         <p:nvSpPr>
-          <p:cNvPr id="23" name="Shape 21"/>
+          <p:cNvPr id="22" name="Shape 20"/>
           <p:cNvSpPr/>
           <p:nvPr/>
         </p:nvSpPr>
@@ -2129,7 +2179,7 @@
       </p:sp>
       <p:sp>
         <p:nvSpPr>
-          <p:cNvPr id="24" name="Shape 22"/>
+          <p:cNvPr id="23" name="Shape 21"/>
           <p:cNvSpPr/>
           <p:nvPr/>
         </p:nvSpPr>
@@ -2152,7 +2202,7 @@
       </p:sp>
       <p:sp>
         <p:nvSpPr>
-          <p:cNvPr id="25" name="Shape 23"/>
+          <p:cNvPr id="24" name="Shape 22"/>
           <p:cNvSpPr/>
           <p:nvPr/>
         </p:nvSpPr>
@@ -2175,7 +2225,7 @@
       </p:sp>
       <p:sp>
         <p:nvSpPr>
-          <p:cNvPr id="26" name="Shape 24"/>
+          <p:cNvPr id="25" name="Shape 23"/>
           <p:cNvSpPr/>
           <p:nvPr/>
         </p:nvSpPr>
@@ -2198,7 +2248,7 @@
       </p:sp>
       <p:sp>
         <p:nvSpPr>
-          <p:cNvPr id="27" name="Text 25"/>
+          <p:cNvPr id="26" name="Text 24"/>
           <p:cNvSpPr txBox="1"/>
           <p:nvPr/>
         </p:nvSpPr>
@@ -2237,7 +2287,7 @@
       </p:sp>
       <p:sp>
         <p:nvSpPr>
-          <p:cNvPr id="28" name="Shape 26"/>
+          <p:cNvPr id="27" name="Shape 25"/>
           <p:cNvSpPr/>
           <p:nvPr/>
         </p:nvSpPr>
@@ -2264,7 +2314,7 @@
       </p:sp>
       <p:sp>
         <p:nvSpPr>
-          <p:cNvPr id="29" name="Text 27"/>
+          <p:cNvPr id="28" name="Text 26"/>
           <p:cNvSpPr txBox="1"/>
           <p:nvPr/>
         </p:nvSpPr>
@@ -2303,7 +2353,7 @@
       </p:sp>
       <p:sp>
         <p:nvSpPr>
-          <p:cNvPr id="30" name="Text 28"/>
+          <p:cNvPr id="29" name="Text 27"/>
           <p:cNvSpPr txBox="1"/>
           <p:nvPr/>
         </p:nvSpPr>
@@ -2342,7 +2392,7 @@
       </p:sp>
       <p:sp>
         <p:nvSpPr>
-          <p:cNvPr id="31" name="Text 29"/>
+          <p:cNvPr id="30" name="Text 28"/>
           <p:cNvSpPr txBox="1"/>
           <p:nvPr/>
         </p:nvSpPr>
@@ -2381,7 +2431,7 @@
       </p:sp>
       <p:sp>
         <p:nvSpPr>
-          <p:cNvPr id="32" name="Shape 30"/>
+          <p:cNvPr id="31" name="Shape 29"/>
           <p:cNvSpPr/>
           <p:nvPr/>
         </p:nvSpPr>
@@ -2408,7 +2458,7 @@
       </p:sp>
       <p:sp>
         <p:nvSpPr>
-          <p:cNvPr id="33" name="Text 31"/>
+          <p:cNvPr id="32" name="Text 30"/>
           <p:cNvSpPr txBox="1"/>
           <p:nvPr/>
         </p:nvSpPr>
@@ -2447,7 +2497,7 @@
       </p:sp>
       <p:sp>
         <p:nvSpPr>
-          <p:cNvPr id="34" name="Text 32"/>
+          <p:cNvPr id="33" name="Text 31"/>
           <p:cNvSpPr txBox="1"/>
           <p:nvPr/>
         </p:nvSpPr>
@@ -2486,7 +2536,7 @@
       </p:sp>
       <p:sp>
         <p:nvSpPr>
-          <p:cNvPr id="35" name="Text 33"/>
+          <p:cNvPr id="34" name="Text 32"/>
           <p:cNvSpPr txBox="1"/>
           <p:nvPr/>
         </p:nvSpPr>
@@ -2525,7 +2575,7 @@
       </p:sp>
       <p:sp>
         <p:nvSpPr>
-          <p:cNvPr id="36" name="Shape 34"/>
+          <p:cNvPr id="35" name="Shape 33"/>
           <p:cNvSpPr/>
           <p:nvPr/>
         </p:nvSpPr>
@@ -2552,7 +2602,7 @@
       </p:sp>
       <p:sp>
         <p:nvSpPr>
-          <p:cNvPr id="37" name="Text 35"/>
+          <p:cNvPr id="36" name="Text 34"/>
           <p:cNvSpPr txBox="1"/>
           <p:nvPr/>
         </p:nvSpPr>
@@ -2591,7 +2641,7 @@
       </p:sp>
       <p:sp>
         <p:nvSpPr>
-          <p:cNvPr id="38" name="Shape 36"/>
+          <p:cNvPr id="37" name="Shape 35"/>
           <p:cNvSpPr/>
           <p:nvPr/>
         </p:nvSpPr>
@@ -2618,7 +2668,7 @@
       </p:sp>
       <p:sp>
         <p:nvSpPr>
-          <p:cNvPr id="39" name="Text 37"/>
+          <p:cNvPr id="38" name="Text 36"/>
           <p:cNvSpPr txBox="1"/>
           <p:nvPr/>
         </p:nvSpPr>
@@ -2657,7 +2707,7 @@
       </p:sp>
       <p:sp>
         <p:nvSpPr>
-          <p:cNvPr id="40" name="Shape 38"/>
+          <p:cNvPr id="39" name="Shape 37"/>
           <p:cNvSpPr/>
           <p:nvPr/>
         </p:nvSpPr>
@@ -2684,7 +2734,7 @@
       </p:sp>
       <p:sp>
         <p:nvSpPr>
-          <p:cNvPr id="41" name="Text 39"/>
+          <p:cNvPr id="40" name="Text 38"/>
           <p:cNvSpPr txBox="1"/>
           <p:nvPr/>
         </p:nvSpPr>
@@ -2723,7 +2773,7 @@
       </p:sp>
       <p:sp>
         <p:nvSpPr>
-          <p:cNvPr id="42" name="Shape 40"/>
+          <p:cNvPr id="41" name="Shape 39"/>
           <p:cNvSpPr/>
           <p:nvPr/>
         </p:nvSpPr>
@@ -2746,7 +2796,7 @@
       </p:sp>
       <p:sp>
         <p:nvSpPr>
-          <p:cNvPr id="43" name="Text 41"/>
+          <p:cNvPr id="42" name="Text 40"/>
           <p:cNvSpPr txBox="1"/>
           <p:nvPr/>
         </p:nvSpPr>
@@ -2785,7 +2835,7 @@
       </p:sp>
       <p:sp>
         <p:nvSpPr>
-          <p:cNvPr id="44" name="Text 42"/>
+          <p:cNvPr id="43" name="Text 41"/>
           <p:cNvSpPr txBox="1"/>
           <p:nvPr/>
         </p:nvSpPr>
@@ -2824,7 +2874,7 @@
       </p:sp>
       <p:sp>
         <p:nvSpPr>
-          <p:cNvPr id="45" name="Text 43"/>
+          <p:cNvPr id="44" name="Text 42"/>
           <p:cNvSpPr txBox="1"/>
           <p:nvPr/>
         </p:nvSpPr>
@@ -2858,6 +2908,45 @@
               <a:t>Out: LabVIEW</a:t>
             </a:r>
             <a:endParaRPr lang="en-US" sz="850" dirty="0"/>
+          </a:p>
+        </p:txBody>
+      </p:sp>
+      <p:sp>
+        <p:nvSpPr>
+          <p:cNvPr id="45" name="Text 43"/>
+          <p:cNvSpPr txBox="1"/>
+          <p:nvPr/>
+        </p:nvSpPr>
+        <p:spPr>
+          <a:xfrm>
+            <a:off x="1079504" y="7150608"/>
+            <a:ext cx="1188720" cy="228600"/>
+          </a:xfrm>
+          <a:prstGeom prst="rect">
+            <a:avLst/>
+          </a:prstGeom>
+          <a:noFill/>
+          <a:ln/>
+        </p:spPr>
+        <p:txBody>
+          <a:bodyPr wrap="square" lIns="0" tIns="0" rIns="0" bIns="0" rtlCol="0" anchor="t"/>
+          <a:lstStyle/>
+          <a:p>
+            <a:pPr indent="0" marL="0">
+              <a:buNone/>
+            </a:pPr>
+            <a:r>
+              <a:rPr lang="en-US" sz="1000" i="1" dirty="0">
+                <a:solidFill>
+                  <a:srgbClr val="1F2933"/>
+                </a:solidFill>
+                <a:latin typeface="Calibri" pitchFamily="34" charset="0"/>
+                <a:ea typeface="Calibri" pitchFamily="34" charset="-122"/>
+                <a:cs typeface="Calibri" pitchFamily="34" charset="-120"/>
+              </a:rPr>
+              <a:t>by Teknosofen</a:t>
+            </a:r>
+            <a:endParaRPr lang="en-US" sz="1000" dirty="0"/>
           </a:p>
         </p:txBody>
       </p:sp>
@@ -3004,11 +3093,11 @@
         <p:spPr>
           <a:xfrm>
             <a:off x="548640" y="1737360"/>
-            <a:ext cx="2240280" cy="2743200"/>
+            <a:ext cx="2192274" cy="2743200"/>
           </a:xfrm>
           <a:prstGeom prst="roundRect">
             <a:avLst>
-              <a:gd name="adj" fmla="val 4898"/>
+              <a:gd name="adj" fmla="val 5005"/>
             </a:avLst>
           </a:prstGeom>
           <a:solidFill>
@@ -3095,7 +3184,7 @@
         <p:spPr>
           <a:xfrm>
             <a:off x="777240" y="2651760"/>
-            <a:ext cx="1783080" cy="411480"/>
+            <a:ext cx="1735074" cy="411480"/>
           </a:xfrm>
           <a:prstGeom prst="rect">
             <a:avLst/>
@@ -3134,7 +3223,7 @@
         <p:spPr>
           <a:xfrm>
             <a:off x="777240" y="3108960"/>
-            <a:ext cx="1783080" cy="1280160"/>
+            <a:ext cx="1735074" cy="1280160"/>
           </a:xfrm>
           <a:prstGeom prst="rect">
             <a:avLst/>
@@ -3172,7 +3261,7 @@
         </p:nvSpPr>
         <p:spPr>
           <a:xfrm>
-            <a:off x="2788920" y="2651760"/>
+            <a:off x="2740914" y="2651760"/>
             <a:ext cx="274320" cy="548640"/>
           </a:xfrm>
           <a:prstGeom prst="rect">
@@ -3211,12 +3300,12 @@
         </p:nvSpPr>
         <p:spPr>
           <a:xfrm>
-            <a:off x="3063240" y="1737360"/>
-            <a:ext cx="2240280" cy="2743200"/>
+            <a:off x="3015234" y="1737360"/>
+            <a:ext cx="2192274" cy="2743200"/>
           </a:xfrm>
           <a:prstGeom prst="roundRect">
             <a:avLst>
-              <a:gd name="adj" fmla="val 4898"/>
+              <a:gd name="adj" fmla="val 5005"/>
             </a:avLst>
           </a:prstGeom>
           <a:solidFill>
@@ -3238,7 +3327,7 @@
         </p:nvSpPr>
         <p:spPr>
           <a:xfrm>
-            <a:off x="3291840" y="1965960"/>
+            <a:off x="3243834" y="1965960"/>
             <a:ext cx="548640" cy="548640"/>
           </a:xfrm>
           <a:prstGeom prst="ellipse">
@@ -3263,7 +3352,7 @@
         </p:nvSpPr>
         <p:spPr>
           <a:xfrm>
-            <a:off x="3291840" y="1965960"/>
+            <a:off x="3243834" y="1965960"/>
             <a:ext cx="548640" cy="548640"/>
           </a:xfrm>
           <a:prstGeom prst="rect">
@@ -3302,8 +3391,8 @@
         </p:nvSpPr>
         <p:spPr>
           <a:xfrm>
-            <a:off x="3291840" y="2651760"/>
-            <a:ext cx="1783080" cy="411480"/>
+            <a:off x="3243834" y="2651760"/>
+            <a:ext cx="1735074" cy="411480"/>
           </a:xfrm>
           <a:prstGeom prst="rect">
             <a:avLst/>
@@ -3341,8 +3430,8 @@
         </p:nvSpPr>
         <p:spPr>
           <a:xfrm>
-            <a:off x="3291840" y="3108960"/>
-            <a:ext cx="1783080" cy="1280160"/>
+            <a:off x="3243834" y="3108960"/>
+            <a:ext cx="1735074" cy="1280160"/>
           </a:xfrm>
           <a:prstGeom prst="rect">
             <a:avLst/>
@@ -3380,7 +3469,7 @@
         </p:nvSpPr>
         <p:spPr>
           <a:xfrm>
-            <a:off x="5303520" y="2651760"/>
+            <a:off x="5207508" y="2651760"/>
             <a:ext cx="274320" cy="548640"/>
           </a:xfrm>
           <a:prstGeom prst="rect">
@@ -3419,12 +3508,12 @@
         </p:nvSpPr>
         <p:spPr>
           <a:xfrm>
-            <a:off x="5577840" y="1737360"/>
-            <a:ext cx="2240280" cy="2743200"/>
+            <a:off x="5481828" y="1737360"/>
+            <a:ext cx="2192274" cy="2743200"/>
           </a:xfrm>
           <a:prstGeom prst="roundRect">
             <a:avLst>
-              <a:gd name="adj" fmla="val 4898"/>
+              <a:gd name="adj" fmla="val 5005"/>
             </a:avLst>
           </a:prstGeom>
           <a:solidFill>
@@ -3446,7 +3535,7 @@
         </p:nvSpPr>
         <p:spPr>
           <a:xfrm>
-            <a:off x="5806440" y="1965960"/>
+            <a:off x="5710428" y="1965960"/>
             <a:ext cx="548640" cy="548640"/>
           </a:xfrm>
           <a:prstGeom prst="ellipse">
@@ -3471,7 +3560,7 @@
         </p:nvSpPr>
         <p:spPr>
           <a:xfrm>
-            <a:off x="5806440" y="1965960"/>
+            <a:off x="5710428" y="1965960"/>
             <a:ext cx="548640" cy="548640"/>
           </a:xfrm>
           <a:prstGeom prst="rect">
@@ -3510,8 +3599,8 @@
         </p:nvSpPr>
         <p:spPr>
           <a:xfrm>
-            <a:off x="5806440" y="2651760"/>
-            <a:ext cx="1783080" cy="411480"/>
+            <a:off x="5710428" y="2651760"/>
+            <a:ext cx="1735074" cy="411480"/>
           </a:xfrm>
           <a:prstGeom prst="rect">
             <a:avLst/>
@@ -3549,8 +3638,8 @@
         </p:nvSpPr>
         <p:spPr>
           <a:xfrm>
-            <a:off x="5806440" y="3108960"/>
-            <a:ext cx="1783080" cy="1280160"/>
+            <a:off x="5710428" y="3108960"/>
+            <a:ext cx="1735074" cy="1280160"/>
           </a:xfrm>
           <a:prstGeom prst="rect">
             <a:avLst/>
@@ -3588,7 +3677,7 @@
         </p:nvSpPr>
         <p:spPr>
           <a:xfrm>
-            <a:off x="7818120" y="2651760"/>
+            <a:off x="7674102" y="2651760"/>
             <a:ext cx="274320" cy="548640"/>
           </a:xfrm>
           <a:prstGeom prst="rect">
@@ -3627,12 +3716,12 @@
         </p:nvSpPr>
         <p:spPr>
           <a:xfrm>
-            <a:off x="8092440" y="1737360"/>
-            <a:ext cx="2240280" cy="2743200"/>
+            <a:off x="7948422" y="1737360"/>
+            <a:ext cx="2192274" cy="2743200"/>
           </a:xfrm>
           <a:prstGeom prst="roundRect">
             <a:avLst>
-              <a:gd name="adj" fmla="val 4898"/>
+              <a:gd name="adj" fmla="val 5005"/>
             </a:avLst>
           </a:prstGeom>
           <a:solidFill>
@@ -3654,7 +3743,7 @@
         </p:nvSpPr>
         <p:spPr>
           <a:xfrm>
-            <a:off x="8321040" y="1965960"/>
+            <a:off x="8177022" y="1965960"/>
             <a:ext cx="548640" cy="548640"/>
           </a:xfrm>
           <a:prstGeom prst="ellipse">
@@ -3679,7 +3768,7 @@
         </p:nvSpPr>
         <p:spPr>
           <a:xfrm>
-            <a:off x="8321040" y="1965960"/>
+            <a:off x="8177022" y="1965960"/>
             <a:ext cx="548640" cy="548640"/>
           </a:xfrm>
           <a:prstGeom prst="rect">
@@ -3718,8 +3807,8 @@
         </p:nvSpPr>
         <p:spPr>
           <a:xfrm>
-            <a:off x="8321040" y="2651760"/>
-            <a:ext cx="1783080" cy="411480"/>
+            <a:off x="8177022" y="2651760"/>
+            <a:ext cx="1735074" cy="411480"/>
           </a:xfrm>
           <a:prstGeom prst="rect">
             <a:avLst/>
@@ -3757,8 +3846,8 @@
         </p:nvSpPr>
         <p:spPr>
           <a:xfrm>
-            <a:off x="8321040" y="3108960"/>
-            <a:ext cx="1783080" cy="1280160"/>
+            <a:off x="8177022" y="3108960"/>
+            <a:ext cx="1735074" cy="1280160"/>
           </a:xfrm>
           <a:prstGeom prst="rect">
             <a:avLst/>
@@ -3974,9 +4063,48 @@
           </a:p>
         </p:txBody>
       </p:sp>
+      <p:sp>
+        <p:nvSpPr>
+          <p:cNvPr id="31" name="Text 29"/>
+          <p:cNvSpPr txBox="1"/>
+          <p:nvPr/>
+        </p:nvSpPr>
+        <p:spPr>
+          <a:xfrm>
+            <a:off x="1079504" y="7150608"/>
+            <a:ext cx="1188720" cy="228600"/>
+          </a:xfrm>
+          <a:prstGeom prst="rect">
+            <a:avLst/>
+          </a:prstGeom>
+          <a:noFill/>
+          <a:ln/>
+        </p:spPr>
+        <p:txBody>
+          <a:bodyPr wrap="square" lIns="0" tIns="0" rIns="0" bIns="0" rtlCol="0" anchor="t"/>
+          <a:lstStyle/>
+          <a:p>
+            <a:pPr indent="0" marL="0">
+              <a:buNone/>
+            </a:pPr>
+            <a:r>
+              <a:rPr lang="en-US" sz="1000" i="1" dirty="0">
+                <a:solidFill>
+                  <a:srgbClr val="1F2933"/>
+                </a:solidFill>
+                <a:latin typeface="Calibri" pitchFamily="34" charset="0"/>
+                <a:ea typeface="Calibri" pitchFamily="34" charset="-122"/>
+                <a:cs typeface="Calibri" pitchFamily="34" charset="-120"/>
+              </a:rPr>
+              <a:t>by Teknosofen</a:t>
+            </a:r>
+            <a:endParaRPr lang="en-US" sz="1000" dirty="0"/>
+          </a:p>
+        </p:txBody>
+      </p:sp>
       <p:pic>
         <p:nvPicPr>
-          <p:cNvPr id="31" name="Image 0" descr="Örnhagen logo">    </p:cNvPr>
+          <p:cNvPr id="32" name="Image 0" descr="Örnhagen logo">    </p:cNvPr>
           <p:cNvPicPr>
             <a:picLocks noChangeAspect="1"/>
           </p:cNvPicPr>
@@ -4000,14 +4128,14 @@
       </p:pic>
       <p:sp>
         <p:nvSpPr>
-          <p:cNvPr id="32" name="Text 29"/>
-          <p:cNvSpPr txBox="1"/>
-          <p:nvPr/>
-        </p:nvSpPr>
-        <p:spPr>
-          <a:xfrm>
-            <a:off x="1079504" y="7150608"/>
-            <a:ext cx="5486400" cy="228600"/>
+          <p:cNvPr id="33" name="Text 30"/>
+          <p:cNvSpPr txBox="1"/>
+          <p:nvPr/>
+        </p:nvSpPr>
+        <p:spPr>
+          <a:xfrm>
+            <a:off x="1975616" y="7150608"/>
+            <a:ext cx="4572000" cy="228600"/>
           </a:xfrm>
           <a:prstGeom prst="rect">
             <a:avLst/>
@@ -4031,7 +4159,7 @@
                 <a:ea typeface="Calibri" pitchFamily="34" charset="-122"/>
                 <a:cs typeface="Calibri" pitchFamily="34" charset="-120"/>
               </a:rPr>
-              <a:t>Eaglehagen CO₂ Monitor  ·  Basic setup</a:t>
+              <a:t>·   Eaglehagen CO₂ Monitor  ·  Basic setup</a:t>
             </a:r>
             <a:endParaRPr lang="en-US" sz="900" dirty="0"/>
           </a:p>
@@ -4039,7 +4167,7 @@
       </p:sp>
       <p:sp>
         <p:nvSpPr>
-          <p:cNvPr id="33" name="Text 30"/>
+          <p:cNvPr id="34" name="Text 31"/>
           <p:cNvSpPr txBox="1"/>
           <p:nvPr/>
         </p:nvSpPr>
@@ -6177,9 +6305,48 @@
           </a:p>
         </p:txBody>
       </p:sp>
+      <p:sp>
+        <p:nvSpPr>
+          <p:cNvPr id="67" name="Text 65"/>
+          <p:cNvSpPr txBox="1"/>
+          <p:nvPr/>
+        </p:nvSpPr>
+        <p:spPr>
+          <a:xfrm>
+            <a:off x="1079504" y="7150608"/>
+            <a:ext cx="1188720" cy="228600"/>
+          </a:xfrm>
+          <a:prstGeom prst="rect">
+            <a:avLst/>
+          </a:prstGeom>
+          <a:noFill/>
+          <a:ln/>
+        </p:spPr>
+        <p:txBody>
+          <a:bodyPr wrap="square" lIns="0" tIns="0" rIns="0" bIns="0" rtlCol="0" anchor="t"/>
+          <a:lstStyle/>
+          <a:p>
+            <a:pPr indent="0" marL="0">
+              <a:buNone/>
+            </a:pPr>
+            <a:r>
+              <a:rPr lang="en-US" sz="1000" i="1" dirty="0">
+                <a:solidFill>
+                  <a:srgbClr val="1F2933"/>
+                </a:solidFill>
+                <a:latin typeface="Calibri" pitchFamily="34" charset="0"/>
+                <a:ea typeface="Calibri" pitchFamily="34" charset="-122"/>
+                <a:cs typeface="Calibri" pitchFamily="34" charset="-120"/>
+              </a:rPr>
+              <a:t>by Teknosofen</a:t>
+            </a:r>
+            <a:endParaRPr lang="en-US" sz="1000" dirty="0"/>
+          </a:p>
+        </p:txBody>
+      </p:sp>
       <p:pic>
         <p:nvPicPr>
-          <p:cNvPr id="67" name="Image 0" descr="Örnhagen logo">    </p:cNvPr>
+          <p:cNvPr id="68" name="Image 0" descr="Örnhagen logo">    </p:cNvPr>
           <p:cNvPicPr>
             <a:picLocks noChangeAspect="1"/>
           </p:cNvPicPr>
@@ -6203,14 +6370,14 @@
       </p:pic>
       <p:sp>
         <p:nvSpPr>
-          <p:cNvPr id="68" name="Text 65"/>
-          <p:cNvSpPr txBox="1"/>
-          <p:nvPr/>
-        </p:nvSpPr>
-        <p:spPr>
-          <a:xfrm>
-            <a:off x="1079504" y="7150608"/>
-            <a:ext cx="5486400" cy="228600"/>
+          <p:cNvPr id="69" name="Text 66"/>
+          <p:cNvSpPr txBox="1"/>
+          <p:nvPr/>
+        </p:nvSpPr>
+        <p:spPr>
+          <a:xfrm>
+            <a:off x="1975616" y="7150608"/>
+            <a:ext cx="4572000" cy="228600"/>
           </a:xfrm>
           <a:prstGeom prst="rect">
             <a:avLst/>
@@ -6234,7 +6401,7 @@
                 <a:ea typeface="Calibri" pitchFamily="34" charset="-122"/>
                 <a:cs typeface="Calibri" pitchFamily="34" charset="-120"/>
               </a:rPr>
-              <a:t>Eaglehagen CO₂ Monitor  ·  Basic setup</a:t>
+              <a:t>·   Eaglehagen CO₂ Monitor  ·  Basic setup</a:t>
             </a:r>
             <a:endParaRPr lang="en-US" sz="900" dirty="0"/>
           </a:p>
@@ -6242,7 +6409,7 @@
       </p:sp>
       <p:sp>
         <p:nvSpPr>
-          <p:cNvPr id="69" name="Text 66"/>
+          <p:cNvPr id="70" name="Text 67"/>
           <p:cNvSpPr txBox="1"/>
           <p:nvPr/>
         </p:nvSpPr>
@@ -7373,9 +7540,48 @@
           </a:p>
         </p:txBody>
       </p:sp>
+      <p:sp>
+        <p:nvSpPr>
+          <p:cNvPr id="32" name="Text 30"/>
+          <p:cNvSpPr txBox="1"/>
+          <p:nvPr/>
+        </p:nvSpPr>
+        <p:spPr>
+          <a:xfrm>
+            <a:off x="1079504" y="7150608"/>
+            <a:ext cx="1188720" cy="228600"/>
+          </a:xfrm>
+          <a:prstGeom prst="rect">
+            <a:avLst/>
+          </a:prstGeom>
+          <a:noFill/>
+          <a:ln/>
+        </p:spPr>
+        <p:txBody>
+          <a:bodyPr wrap="square" lIns="0" tIns="0" rIns="0" bIns="0" rtlCol="0" anchor="t"/>
+          <a:lstStyle/>
+          <a:p>
+            <a:pPr indent="0" marL="0">
+              <a:buNone/>
+            </a:pPr>
+            <a:r>
+              <a:rPr lang="en-US" sz="1000" i="1" dirty="0">
+                <a:solidFill>
+                  <a:srgbClr val="1F2933"/>
+                </a:solidFill>
+                <a:latin typeface="Calibri" pitchFamily="34" charset="0"/>
+                <a:ea typeface="Calibri" pitchFamily="34" charset="-122"/>
+                <a:cs typeface="Calibri" pitchFamily="34" charset="-120"/>
+              </a:rPr>
+              <a:t>by Teknosofen</a:t>
+            </a:r>
+            <a:endParaRPr lang="en-US" sz="1000" dirty="0"/>
+          </a:p>
+        </p:txBody>
+      </p:sp>
       <p:pic>
         <p:nvPicPr>
-          <p:cNvPr id="32" name="Image 0" descr="Örnhagen logo">    </p:cNvPr>
+          <p:cNvPr id="33" name="Image 0" descr="Örnhagen logo">    </p:cNvPr>
           <p:cNvPicPr>
             <a:picLocks noChangeAspect="1"/>
           </p:cNvPicPr>
@@ -7399,14 +7605,14 @@
       </p:pic>
       <p:sp>
         <p:nvSpPr>
-          <p:cNvPr id="33" name="Text 30"/>
-          <p:cNvSpPr txBox="1"/>
-          <p:nvPr/>
-        </p:nvSpPr>
-        <p:spPr>
-          <a:xfrm>
-            <a:off x="1079504" y="7150608"/>
-            <a:ext cx="5486400" cy="228600"/>
+          <p:cNvPr id="34" name="Text 31"/>
+          <p:cNvSpPr txBox="1"/>
+          <p:nvPr/>
+        </p:nvSpPr>
+        <p:spPr>
+          <a:xfrm>
+            <a:off x="1975616" y="7150608"/>
+            <a:ext cx="4572000" cy="228600"/>
           </a:xfrm>
           <a:prstGeom prst="rect">
             <a:avLst/>
@@ -7430,7 +7636,7 @@
                 <a:ea typeface="Calibri" pitchFamily="34" charset="-122"/>
                 <a:cs typeface="Calibri" pitchFamily="34" charset="-120"/>
               </a:rPr>
-              <a:t>Eaglehagen CO₂ Monitor  ·  Basic setup</a:t>
+              <a:t>·   Eaglehagen CO₂ Monitor  ·  Basic setup</a:t>
             </a:r>
             <a:endParaRPr lang="en-US" sz="900" dirty="0"/>
           </a:p>
@@ -7438,7 +7644,7 @@
       </p:sp>
       <p:sp>
         <p:nvSpPr>
-          <p:cNvPr id="34" name="Text 31"/>
+          <p:cNvPr id="35" name="Text 32"/>
           <p:cNvSpPr txBox="1"/>
           <p:nvPr/>
         </p:nvSpPr>
@@ -10036,15 +10242,54 @@
                 <a:ea typeface="Calibri" pitchFamily="34" charset="-122"/>
                 <a:cs typeface="Calibri" pitchFamily="34" charset="-120"/>
               </a:rPr>
-              <a:t>The page keeps the last 2 minutes. Save within 2 minutes of an event, and keep the page open: closing or reloading it loses the data.</a:t>
+              <a:t>The page keeps the last 2 minutes: save soon after an event and keep the page open. For longer recordings, use the PC monitor page (page 7).</a:t>
             </a:r>
             <a:endParaRPr lang="en-US" sz="1300" dirty="0"/>
+          </a:p>
+        </p:txBody>
+      </p:sp>
+      <p:sp>
+        <p:nvSpPr>
+          <p:cNvPr id="84" name="Text 82"/>
+          <p:cNvSpPr txBox="1"/>
+          <p:nvPr/>
+        </p:nvSpPr>
+        <p:spPr>
+          <a:xfrm>
+            <a:off x="1079504" y="7150608"/>
+            <a:ext cx="1188720" cy="228600"/>
+          </a:xfrm>
+          <a:prstGeom prst="rect">
+            <a:avLst/>
+          </a:prstGeom>
+          <a:noFill/>
+          <a:ln/>
+        </p:spPr>
+        <p:txBody>
+          <a:bodyPr wrap="square" lIns="0" tIns="0" rIns="0" bIns="0" rtlCol="0" anchor="t"/>
+          <a:lstStyle/>
+          <a:p>
+            <a:pPr indent="0" marL="0">
+              <a:buNone/>
+            </a:pPr>
+            <a:r>
+              <a:rPr lang="en-US" sz="1000" i="1" dirty="0">
+                <a:solidFill>
+                  <a:srgbClr val="1F2933"/>
+                </a:solidFill>
+                <a:latin typeface="Calibri" pitchFamily="34" charset="0"/>
+                <a:ea typeface="Calibri" pitchFamily="34" charset="-122"/>
+                <a:cs typeface="Calibri" pitchFamily="34" charset="-120"/>
+              </a:rPr>
+              <a:t>by Teknosofen</a:t>
+            </a:r>
+            <a:endParaRPr lang="en-US" sz="1000" dirty="0"/>
           </a:p>
         </p:txBody>
       </p:sp>
       <p:pic>
         <p:nvPicPr>
-          <p:cNvPr id="84" name="Image 0" descr="Örnhagen logo">    </p:cNvPr>
+          <p:cNvPr id="85" name="Image 0" descr="Örnhagen logo">    </p:cNvPr>
           <p:cNvPicPr>
             <a:picLocks noChangeAspect="1"/>
           </p:cNvPicPr>
@@ -10068,14 +10313,14 @@
       </p:pic>
       <p:sp>
         <p:nvSpPr>
-          <p:cNvPr id="85" name="Text 82"/>
-          <p:cNvSpPr txBox="1"/>
-          <p:nvPr/>
-        </p:nvSpPr>
-        <p:spPr>
-          <a:xfrm>
-            <a:off x="1079504" y="7150608"/>
-            <a:ext cx="5486400" cy="228600"/>
+          <p:cNvPr id="86" name="Text 83"/>
+          <p:cNvSpPr txBox="1"/>
+          <p:nvPr/>
+        </p:nvSpPr>
+        <p:spPr>
+          <a:xfrm>
+            <a:off x="1975616" y="7150608"/>
+            <a:ext cx="4572000" cy="228600"/>
           </a:xfrm>
           <a:prstGeom prst="rect">
             <a:avLst/>
@@ -10099,7 +10344,7 @@
                 <a:ea typeface="Calibri" pitchFamily="34" charset="-122"/>
                 <a:cs typeface="Calibri" pitchFamily="34" charset="-120"/>
               </a:rPr>
-              <a:t>Eaglehagen CO₂ Monitor  ·  Basic setup</a:t>
+              <a:t>·   Eaglehagen CO₂ Monitor  ·  Basic setup</a:t>
             </a:r>
             <a:endParaRPr lang="en-US" sz="900" dirty="0"/>
           </a:p>
@@ -10107,7 +10352,7 @@
       </p:sp>
       <p:sp>
         <p:nvSpPr>
-          <p:cNvPr id="86" name="Text 83"/>
+          <p:cNvPr id="87" name="Text 84"/>
           <p:cNvSpPr txBox="1"/>
           <p:nvPr/>
         </p:nvSpPr>
@@ -11203,15 +11448,68 @@
                 <a:ea typeface="Calibri" pitchFamily="34" charset="-122"/>
                 <a:cs typeface="Calibri" pitchFamily="34" charset="-120"/>
               </a:rPr>
-              <a:t>plain text lines (CO₂ kPa, O₂ %, RR, volume, status) for Excel, Python or a terminal. Lines starting with # are messages and can be skipped.</a:t>
+              <a:t>plain text lines (CO₂ kPa, O₂ %, RR, volume, status) for Excel, Python or a terminal. Lines starting with # are messages and can be skipped. </a:t>
+            </a:r>
+            <a:pPr indent="0" marL="0">
+              <a:buNone/>
+            </a:pPr>
+            <a:r>
+              <a:rPr lang="en-US" sz="1200" b="1" dirty="0">
+                <a:solidFill>
+                  <a:srgbClr val="184D7B"/>
+                </a:solidFill>
+                <a:latin typeface="Calibri" pitchFamily="34" charset="0"/>
+                <a:ea typeface="Calibri" pitchFamily="34" charset="-122"/>
+                <a:cs typeface="Calibri" pitchFamily="34" charset="-120"/>
+              </a:rPr>
+              <a:t>No LabVIEW? See the next page.</a:t>
             </a:r>
             <a:endParaRPr lang="en-US" sz="1200" dirty="0"/>
+          </a:p>
+        </p:txBody>
+      </p:sp>
+      <p:sp>
+        <p:nvSpPr>
+          <p:cNvPr id="30" name="Text 28"/>
+          <p:cNvSpPr txBox="1"/>
+          <p:nvPr/>
+        </p:nvSpPr>
+        <p:spPr>
+          <a:xfrm>
+            <a:off x="1079504" y="7150608"/>
+            <a:ext cx="1188720" cy="228600"/>
+          </a:xfrm>
+          <a:prstGeom prst="rect">
+            <a:avLst/>
+          </a:prstGeom>
+          <a:noFill/>
+          <a:ln/>
+        </p:spPr>
+        <p:txBody>
+          <a:bodyPr wrap="square" lIns="0" tIns="0" rIns="0" bIns="0" rtlCol="0" anchor="t"/>
+          <a:lstStyle/>
+          <a:p>
+            <a:pPr indent="0" marL="0">
+              <a:buNone/>
+            </a:pPr>
+            <a:r>
+              <a:rPr lang="en-US" sz="1000" i="1" dirty="0">
+                <a:solidFill>
+                  <a:srgbClr val="1F2933"/>
+                </a:solidFill>
+                <a:latin typeface="Calibri" pitchFamily="34" charset="0"/>
+                <a:ea typeface="Calibri" pitchFamily="34" charset="-122"/>
+                <a:cs typeface="Calibri" pitchFamily="34" charset="-120"/>
+              </a:rPr>
+              <a:t>by Teknosofen</a:t>
+            </a:r>
+            <a:endParaRPr lang="en-US" sz="1000" dirty="0"/>
           </a:p>
         </p:txBody>
       </p:sp>
       <p:pic>
         <p:nvPicPr>
-          <p:cNvPr id="30" name="Image 0" descr="Örnhagen logo">    </p:cNvPr>
+          <p:cNvPr id="31" name="Image 0" descr="Örnhagen logo">    </p:cNvPr>
           <p:cNvPicPr>
             <a:picLocks noChangeAspect="1"/>
           </p:cNvPicPr>
@@ -11235,14 +11533,14 @@
       </p:pic>
       <p:sp>
         <p:nvSpPr>
-          <p:cNvPr id="31" name="Text 28"/>
-          <p:cNvSpPr txBox="1"/>
-          <p:nvPr/>
-        </p:nvSpPr>
-        <p:spPr>
-          <a:xfrm>
-            <a:off x="1079504" y="7150608"/>
-            <a:ext cx="5486400" cy="228600"/>
+          <p:cNvPr id="32" name="Text 29"/>
+          <p:cNvSpPr txBox="1"/>
+          <p:nvPr/>
+        </p:nvSpPr>
+        <p:spPr>
+          <a:xfrm>
+            <a:off x="1975616" y="7150608"/>
+            <a:ext cx="4572000" cy="228600"/>
           </a:xfrm>
           <a:prstGeom prst="rect">
             <a:avLst/>
@@ -11266,7 +11564,7 @@
                 <a:ea typeface="Calibri" pitchFamily="34" charset="-122"/>
                 <a:cs typeface="Calibri" pitchFamily="34" charset="-120"/>
               </a:rPr>
-              <a:t>Eaglehagen CO₂ Monitor  ·  Basic setup</a:t>
+              <a:t>·   Eaglehagen CO₂ Monitor  ·  Basic setup</a:t>
             </a:r>
             <a:endParaRPr lang="en-US" sz="900" dirty="0"/>
           </a:p>
@@ -11274,7 +11572,7 @@
       </p:sp>
       <p:sp>
         <p:nvSpPr>
-          <p:cNvPr id="32" name="Text 29"/>
+          <p:cNvPr id="33" name="Text 30"/>
           <p:cNvSpPr txBox="1"/>
           <p:nvPr/>
         </p:nvSpPr>
@@ -11376,7 +11674,7 @@
                 <a:ea typeface="Cambria" pitchFamily="34" charset="-122"/>
                 <a:cs typeface="Cambria" pitchFamily="34" charset="-120"/>
               </a:rPr>
-              <a:t>If something is wrong</a:t>
+              <a:t>Monitoring on a PC without LabVIEW</a:t>
             </a:r>
             <a:endParaRPr lang="en-US" sz="3200" dirty="0"/>
           </a:p>
@@ -11415,6 +11713,1037 @@
                 <a:ea typeface="Calibri" pitchFamily="34" charset="-122"/>
                 <a:cs typeface="Calibri" pitchFamily="34" charset="-120"/>
               </a:rPr>
+              <a:t>A ready-made page for Chrome or Edge: live values, charts and CSV recording over USB</a:t>
+            </a:r>
+            <a:endParaRPr lang="en-US" sz="1500" dirty="0"/>
+          </a:p>
+        </p:txBody>
+      </p:sp>
+      <p:sp>
+        <p:nvSpPr>
+          <p:cNvPr id="4" name="Shape 2"/>
+          <p:cNvSpPr/>
+          <p:nvPr/>
+        </p:nvSpPr>
+        <p:spPr>
+          <a:xfrm>
+            <a:off x="493776" y="1591056"/>
+            <a:ext cx="5184648" cy="4338828"/>
+          </a:xfrm>
+          <a:prstGeom prst="roundRect">
+            <a:avLst>
+              <a:gd name="adj" fmla="val 1686"/>
+            </a:avLst>
+          </a:prstGeom>
+          <a:solidFill>
+            <a:srgbClr val="FFFFFF"/>
+          </a:solidFill>
+          <a:ln w="12700">
+            <a:solidFill>
+              <a:srgbClr val="CBD5DF"/>
+            </a:solidFill>
+            <a:prstDash val="solid"/>
+          </a:ln>
+        </p:spPr>
+      </p:sp>
+      <p:pic>
+        <p:nvPicPr>
+          <p:cNvPr id="5" name="Image 0" descr="Screenshot of the PC monitor page">    </p:cNvPr>
+          <p:cNvPicPr>
+            <a:picLocks noChangeAspect="1"/>
+          </p:cNvPicPr>
+          <p:nvPr/>
+        </p:nvPicPr>
+        <p:blipFill>
+          <a:blip r:embed="rId1"/>
+          <a:stretch>
+            <a:fillRect/>
+          </a:stretch>
+        </p:blipFill>
+        <p:spPr>
+          <a:xfrm>
+            <a:off x="548640" y="1645920"/>
+            <a:ext cx="5074920" cy="4229100"/>
+          </a:xfrm>
+          <a:prstGeom prst="rect">
+            <a:avLst/>
+          </a:prstGeom>
+        </p:spPr>
+      </p:pic>
+      <p:sp>
+        <p:nvSpPr>
+          <p:cNvPr id="6" name="Text 3"/>
+          <p:cNvSpPr txBox="1"/>
+          <p:nvPr/>
+        </p:nvSpPr>
+        <p:spPr>
+          <a:xfrm>
+            <a:off x="548640" y="5984748"/>
+            <a:ext cx="5074920" cy="274320"/>
+          </a:xfrm>
+          <a:prstGeom prst="rect">
+            <a:avLst/>
+          </a:prstGeom>
+          <a:noFill/>
+          <a:ln/>
+        </p:spPr>
+        <p:txBody>
+          <a:bodyPr wrap="square" lIns="0" tIns="0" rIns="0" bIns="0" rtlCol="0" anchor="t"/>
+          <a:lstStyle/>
+          <a:p>
+            <a:pPr algn="ctr" indent="0" marL="0">
+              <a:buNone/>
+            </a:pPr>
+            <a:r>
+              <a:rPr lang="en-US" sz="1100" dirty="0">
+                <a:solidFill>
+                  <a:srgbClr val="5B6770"/>
+                </a:solidFill>
+                <a:latin typeface="Calibri" pitchFamily="34" charset="0"/>
+                <a:ea typeface="Calibri" pitchFamily="34" charset="-122"/>
+                <a:cs typeface="Calibri" pitchFamily="34" charset="-120"/>
+              </a:rPr>
+              <a:t>The monitor page, light theme</a:t>
+            </a:r>
+            <a:endParaRPr lang="en-US" sz="1100" dirty="0"/>
+          </a:p>
+        </p:txBody>
+      </p:sp>
+      <p:sp>
+        <p:nvSpPr>
+          <p:cNvPr id="7" name="Shape 4"/>
+          <p:cNvSpPr/>
+          <p:nvPr/>
+        </p:nvSpPr>
+        <p:spPr>
+          <a:xfrm>
+            <a:off x="5989320" y="1645920"/>
+            <a:ext cx="4151376" cy="1097280"/>
+          </a:xfrm>
+          <a:prstGeom prst="roundRect">
+            <a:avLst>
+              <a:gd name="adj" fmla="val 10000"/>
+            </a:avLst>
+          </a:prstGeom>
+          <a:solidFill>
+            <a:srgbClr val="E8F1F8"/>
+          </a:solidFill>
+          <a:ln w="12700">
+            <a:solidFill>
+              <a:srgbClr val="E8F1F8"/>
+            </a:solidFill>
+            <a:prstDash val="solid"/>
+          </a:ln>
+        </p:spPr>
+      </p:sp>
+      <p:sp>
+        <p:nvSpPr>
+          <p:cNvPr id="8" name="Text 5"/>
+          <p:cNvSpPr txBox="1"/>
+          <p:nvPr/>
+        </p:nvSpPr>
+        <p:spPr>
+          <a:xfrm>
+            <a:off x="6217920" y="1737360"/>
+            <a:ext cx="3694176" cy="914400"/>
+          </a:xfrm>
+          <a:prstGeom prst="rect">
+            <a:avLst/>
+          </a:prstGeom>
+          <a:noFill/>
+          <a:ln/>
+        </p:spPr>
+        <p:txBody>
+          <a:bodyPr wrap="square" lIns="0" tIns="0" rIns="0" bIns="0" rtlCol="0" anchor="ctr"/>
+          <a:lstStyle/>
+          <a:p>
+            <a:pPr indent="0" marL="0">
+              <a:buNone/>
+            </a:pPr>
+            <a:r>
+              <a:rPr lang="en-US" sz="1600" b="1" dirty="0">
+                <a:solidFill>
+                  <a:srgbClr val="184D7B"/>
+                </a:solidFill>
+                <a:latin typeface="Calibri" pitchFamily="34" charset="0"/>
+                <a:ea typeface="Calibri" pitchFamily="34" charset="-122"/>
+                <a:cs typeface="Calibri" pitchFamily="34" charset="-120"/>
+              </a:rPr>
+              <a:t>Accepts both output formats</a:t>
+            </a:r>
+            <a:endParaRPr lang="en-US" sz="1300" dirty="0"/>
+          </a:p>
+          <a:p>
+            <a:pPr indent="0" marL="0">
+              <a:buNone/>
+            </a:pPr>
+            <a:r>
+              <a:rPr lang="en-US" sz="1300" dirty="0">
+                <a:solidFill>
+                  <a:srgbClr val="1F2933"/>
+                </a:solidFill>
+                <a:latin typeface="Calibri" pitchFamily="34" charset="0"/>
+                <a:ea typeface="Calibri" pitchFamily="34" charset="-122"/>
+                <a:cs typeface="Calibri" pitchFamily="34" charset="-120"/>
+              </a:rPr>
+              <a:t>LabVIEW and ASCII are detected automatically, even if BOOT is pressed while connected.</a:t>
+            </a:r>
+            <a:endParaRPr lang="en-US" sz="1300" dirty="0"/>
+          </a:p>
+        </p:txBody>
+      </p:sp>
+      <p:sp>
+        <p:nvSpPr>
+          <p:cNvPr id="9" name="Shape 6"/>
+          <p:cNvSpPr/>
+          <p:nvPr/>
+        </p:nvSpPr>
+        <p:spPr>
+          <a:xfrm>
+            <a:off x="5989320" y="3017520"/>
+            <a:ext cx="420624" cy="420624"/>
+          </a:xfrm>
+          <a:prstGeom prst="ellipse">
+            <a:avLst/>
+          </a:prstGeom>
+          <a:solidFill>
+            <a:srgbClr val="5292BD"/>
+          </a:solidFill>
+          <a:ln w="12700">
+            <a:solidFill>
+              <a:srgbClr val="5292BD"/>
+            </a:solidFill>
+            <a:prstDash val="solid"/>
+          </a:ln>
+        </p:spPr>
+      </p:sp>
+      <p:sp>
+        <p:nvSpPr>
+          <p:cNvPr id="10" name="Text 7"/>
+          <p:cNvSpPr txBox="1"/>
+          <p:nvPr/>
+        </p:nvSpPr>
+        <p:spPr>
+          <a:xfrm>
+            <a:off x="5989320" y="3017520"/>
+            <a:ext cx="420624" cy="420624"/>
+          </a:xfrm>
+          <a:prstGeom prst="rect">
+            <a:avLst/>
+          </a:prstGeom>
+          <a:noFill/>
+          <a:ln/>
+        </p:spPr>
+        <p:txBody>
+          <a:bodyPr wrap="square" lIns="0" tIns="0" rIns="0" bIns="0" rtlCol="0" anchor="ctr"/>
+          <a:lstStyle/>
+          <a:p>
+            <a:pPr algn="ctr" indent="0" marL="0">
+              <a:buNone/>
+            </a:pPr>
+            <a:r>
+              <a:rPr lang="en-US" sz="1196" b="1" dirty="0">
+                <a:solidFill>
+                  <a:srgbClr val="FFFFFF"/>
+                </a:solidFill>
+                <a:latin typeface="Cambria" pitchFamily="34" charset="0"/>
+                <a:ea typeface="Cambria" pitchFamily="34" charset="-122"/>
+                <a:cs typeface="Cambria" pitchFamily="34" charset="-120"/>
+              </a:rPr>
+              <a:t>1</a:t>
+            </a:r>
+            <a:endParaRPr lang="en-US" sz="1196" dirty="0"/>
+          </a:p>
+        </p:txBody>
+      </p:sp>
+      <p:sp>
+        <p:nvSpPr>
+          <p:cNvPr id="11" name="Text 8"/>
+          <p:cNvSpPr txBox="1"/>
+          <p:nvPr/>
+        </p:nvSpPr>
+        <p:spPr>
+          <a:xfrm>
+            <a:off x="6583680" y="2980944"/>
+            <a:ext cx="3557016" cy="310896"/>
+          </a:xfrm>
+          <a:prstGeom prst="rect">
+            <a:avLst/>
+          </a:prstGeom>
+          <a:noFill/>
+          <a:ln/>
+        </p:spPr>
+        <p:txBody>
+          <a:bodyPr wrap="square" lIns="0" tIns="0" rIns="0" bIns="0" rtlCol="0" anchor="ctr"/>
+          <a:lstStyle/>
+          <a:p>
+            <a:pPr indent="0" marL="0">
+              <a:buNone/>
+            </a:pPr>
+            <a:r>
+              <a:rPr lang="en-US" sz="1500" b="1" dirty="0">
+                <a:solidFill>
+                  <a:srgbClr val="184D7B"/>
+                </a:solidFill>
+                <a:latin typeface="Calibri" pitchFamily="34" charset="0"/>
+                <a:ea typeface="Calibri" pitchFamily="34" charset="-122"/>
+                <a:cs typeface="Calibri" pitchFamily="34" charset="-120"/>
+              </a:rPr>
+              <a:t>Download it over WiFi (once)</a:t>
+            </a:r>
+            <a:endParaRPr lang="en-US" sz="1500" dirty="0"/>
+          </a:p>
+        </p:txBody>
+      </p:sp>
+      <p:sp>
+        <p:nvSpPr>
+          <p:cNvPr id="12" name="Text 9"/>
+          <p:cNvSpPr txBox="1"/>
+          <p:nvPr/>
+        </p:nvSpPr>
+        <p:spPr>
+          <a:xfrm>
+            <a:off x="6583680" y="3291840"/>
+            <a:ext cx="3557016" cy="457200"/>
+          </a:xfrm>
+          <a:prstGeom prst="rect">
+            <a:avLst/>
+          </a:prstGeom>
+          <a:noFill/>
+          <a:ln/>
+        </p:spPr>
+        <p:txBody>
+          <a:bodyPr wrap="square" lIns="0" tIns="0" rIns="0" bIns="0" rtlCol="0" anchor="t"/>
+          <a:lstStyle/>
+          <a:p>
+            <a:pPr indent="0" marL="0">
+              <a:buNone/>
+            </a:pPr>
+            <a:r>
+              <a:rPr lang="en-US" sz="1250" dirty="0">
+                <a:solidFill>
+                  <a:srgbClr val="1F2933"/>
+                </a:solidFill>
+                <a:latin typeface="Calibri" pitchFamily="34" charset="0"/>
+                <a:ea typeface="Calibri" pitchFamily="34" charset="-122"/>
+                <a:cs typeface="Calibri" pitchFamily="34" charset="-120"/>
+              </a:rPr>
+              <a:t>Join EAGLEHAGEN, open eaglehagen.local and click “Download” at the bottom.</a:t>
+            </a:r>
+            <a:endParaRPr lang="en-US" sz="1250" dirty="0"/>
+          </a:p>
+        </p:txBody>
+      </p:sp>
+      <p:sp>
+        <p:nvSpPr>
+          <p:cNvPr id="13" name="Shape 10"/>
+          <p:cNvSpPr/>
+          <p:nvPr/>
+        </p:nvSpPr>
+        <p:spPr>
+          <a:xfrm>
+            <a:off x="5989320" y="3886200"/>
+            <a:ext cx="420624" cy="420624"/>
+          </a:xfrm>
+          <a:prstGeom prst="ellipse">
+            <a:avLst/>
+          </a:prstGeom>
+          <a:solidFill>
+            <a:srgbClr val="5292BD"/>
+          </a:solidFill>
+          <a:ln w="12700">
+            <a:solidFill>
+              <a:srgbClr val="5292BD"/>
+            </a:solidFill>
+            <a:prstDash val="solid"/>
+          </a:ln>
+        </p:spPr>
+      </p:sp>
+      <p:sp>
+        <p:nvSpPr>
+          <p:cNvPr id="14" name="Text 11"/>
+          <p:cNvSpPr txBox="1"/>
+          <p:nvPr/>
+        </p:nvSpPr>
+        <p:spPr>
+          <a:xfrm>
+            <a:off x="5989320" y="3886200"/>
+            <a:ext cx="420624" cy="420624"/>
+          </a:xfrm>
+          <a:prstGeom prst="rect">
+            <a:avLst/>
+          </a:prstGeom>
+          <a:noFill/>
+          <a:ln/>
+        </p:spPr>
+        <p:txBody>
+          <a:bodyPr wrap="square" lIns="0" tIns="0" rIns="0" bIns="0" rtlCol="0" anchor="ctr"/>
+          <a:lstStyle/>
+          <a:p>
+            <a:pPr algn="ctr" indent="0" marL="0">
+              <a:buNone/>
+            </a:pPr>
+            <a:r>
+              <a:rPr lang="en-US" sz="1196" b="1" dirty="0">
+                <a:solidFill>
+                  <a:srgbClr val="FFFFFF"/>
+                </a:solidFill>
+                <a:latin typeface="Cambria" pitchFamily="34" charset="0"/>
+                <a:ea typeface="Cambria" pitchFamily="34" charset="-122"/>
+                <a:cs typeface="Cambria" pitchFamily="34" charset="-120"/>
+              </a:rPr>
+              <a:t>2</a:t>
+            </a:r>
+            <a:endParaRPr lang="en-US" sz="1196" dirty="0"/>
+          </a:p>
+        </p:txBody>
+      </p:sp>
+      <p:sp>
+        <p:nvSpPr>
+          <p:cNvPr id="15" name="Text 12"/>
+          <p:cNvSpPr txBox="1"/>
+          <p:nvPr/>
+        </p:nvSpPr>
+        <p:spPr>
+          <a:xfrm>
+            <a:off x="6583680" y="3849624"/>
+            <a:ext cx="3557016" cy="310896"/>
+          </a:xfrm>
+          <a:prstGeom prst="rect">
+            <a:avLst/>
+          </a:prstGeom>
+          <a:noFill/>
+          <a:ln/>
+        </p:spPr>
+        <p:txBody>
+          <a:bodyPr wrap="square" lIns="0" tIns="0" rIns="0" bIns="0" rtlCol="0" anchor="ctr"/>
+          <a:lstStyle/>
+          <a:p>
+            <a:pPr indent="0" marL="0">
+              <a:buNone/>
+            </a:pPr>
+            <a:r>
+              <a:rPr lang="en-US" sz="1500" b="1" dirty="0">
+                <a:solidFill>
+                  <a:srgbClr val="184D7B"/>
+                </a:solidFill>
+                <a:latin typeface="Calibri" pitchFamily="34" charset="0"/>
+                <a:ea typeface="Calibri" pitchFamily="34" charset="-122"/>
+                <a:cs typeface="Calibri" pitchFamily="34" charset="-120"/>
+              </a:rPr>
+              <a:t>Plug in the USB cable</a:t>
+            </a:r>
+            <a:endParaRPr lang="en-US" sz="1500" dirty="0"/>
+          </a:p>
+        </p:txBody>
+      </p:sp>
+      <p:sp>
+        <p:nvSpPr>
+          <p:cNvPr id="16" name="Text 13"/>
+          <p:cNvSpPr txBox="1"/>
+          <p:nvPr/>
+        </p:nvSpPr>
+        <p:spPr>
+          <a:xfrm>
+            <a:off x="6583680" y="4160520"/>
+            <a:ext cx="3557016" cy="457200"/>
+          </a:xfrm>
+          <a:prstGeom prst="rect">
+            <a:avLst/>
+          </a:prstGeom>
+          <a:noFill/>
+          <a:ln/>
+        </p:spPr>
+        <p:txBody>
+          <a:bodyPr wrap="square" lIns="0" tIns="0" rIns="0" bIns="0" rtlCol="0" anchor="t"/>
+          <a:lstStyle/>
+          <a:p>
+            <a:pPr indent="0" marL="0">
+              <a:buNone/>
+            </a:pPr>
+            <a:r>
+              <a:rPr lang="en-US" sz="1250" dirty="0">
+                <a:solidFill>
+                  <a:srgbClr val="1F2933"/>
+                </a:solidFill>
+                <a:latin typeface="Calibri" pitchFamily="34" charset="0"/>
+                <a:ea typeface="Calibri" pitchFamily="34" charset="-122"/>
+                <a:cs typeface="Calibri" pitchFamily="34" charset="-120"/>
+              </a:rPr>
+              <a:t>Close LabVIEW first: only one program can use the COM port.</a:t>
+            </a:r>
+            <a:endParaRPr lang="en-US" sz="1250" dirty="0"/>
+          </a:p>
+        </p:txBody>
+      </p:sp>
+      <p:sp>
+        <p:nvSpPr>
+          <p:cNvPr id="17" name="Shape 14"/>
+          <p:cNvSpPr/>
+          <p:nvPr/>
+        </p:nvSpPr>
+        <p:spPr>
+          <a:xfrm>
+            <a:off x="5989320" y="4754880"/>
+            <a:ext cx="420624" cy="420624"/>
+          </a:xfrm>
+          <a:prstGeom prst="ellipse">
+            <a:avLst/>
+          </a:prstGeom>
+          <a:solidFill>
+            <a:srgbClr val="5292BD"/>
+          </a:solidFill>
+          <a:ln w="12700">
+            <a:solidFill>
+              <a:srgbClr val="5292BD"/>
+            </a:solidFill>
+            <a:prstDash val="solid"/>
+          </a:ln>
+        </p:spPr>
+      </p:sp>
+      <p:sp>
+        <p:nvSpPr>
+          <p:cNvPr id="18" name="Text 15"/>
+          <p:cNvSpPr txBox="1"/>
+          <p:nvPr/>
+        </p:nvSpPr>
+        <p:spPr>
+          <a:xfrm>
+            <a:off x="5989320" y="4754880"/>
+            <a:ext cx="420624" cy="420624"/>
+          </a:xfrm>
+          <a:prstGeom prst="rect">
+            <a:avLst/>
+          </a:prstGeom>
+          <a:noFill/>
+          <a:ln/>
+        </p:spPr>
+        <p:txBody>
+          <a:bodyPr wrap="square" lIns="0" tIns="0" rIns="0" bIns="0" rtlCol="0" anchor="ctr"/>
+          <a:lstStyle/>
+          <a:p>
+            <a:pPr algn="ctr" indent="0" marL="0">
+              <a:buNone/>
+            </a:pPr>
+            <a:r>
+              <a:rPr lang="en-US" sz="1196" b="1" dirty="0">
+                <a:solidFill>
+                  <a:srgbClr val="FFFFFF"/>
+                </a:solidFill>
+                <a:latin typeface="Cambria" pitchFamily="34" charset="0"/>
+                <a:ea typeface="Cambria" pitchFamily="34" charset="-122"/>
+                <a:cs typeface="Cambria" pitchFamily="34" charset="-120"/>
+              </a:rPr>
+              <a:t>3</a:t>
+            </a:r>
+            <a:endParaRPr lang="en-US" sz="1196" dirty="0"/>
+          </a:p>
+        </p:txBody>
+      </p:sp>
+      <p:sp>
+        <p:nvSpPr>
+          <p:cNvPr id="19" name="Text 16"/>
+          <p:cNvSpPr txBox="1"/>
+          <p:nvPr/>
+        </p:nvSpPr>
+        <p:spPr>
+          <a:xfrm>
+            <a:off x="6583680" y="4718304"/>
+            <a:ext cx="3557016" cy="310896"/>
+          </a:xfrm>
+          <a:prstGeom prst="rect">
+            <a:avLst/>
+          </a:prstGeom>
+          <a:noFill/>
+          <a:ln/>
+        </p:spPr>
+        <p:txBody>
+          <a:bodyPr wrap="square" lIns="0" tIns="0" rIns="0" bIns="0" rtlCol="0" anchor="ctr"/>
+          <a:lstStyle/>
+          <a:p>
+            <a:pPr indent="0" marL="0">
+              <a:buNone/>
+            </a:pPr>
+            <a:r>
+              <a:rPr lang="en-US" sz="1500" b="1" dirty="0">
+                <a:solidFill>
+                  <a:srgbClr val="184D7B"/>
+                </a:solidFill>
+                <a:latin typeface="Calibri" pitchFamily="34" charset="0"/>
+                <a:ea typeface="Calibri" pitchFamily="34" charset="-122"/>
+                <a:cs typeface="Calibri" pitchFamily="34" charset="-120"/>
+              </a:rPr>
+              <a:t>Open the saved file</a:t>
+            </a:r>
+            <a:endParaRPr lang="en-US" sz="1500" dirty="0"/>
+          </a:p>
+        </p:txBody>
+      </p:sp>
+      <p:sp>
+        <p:nvSpPr>
+          <p:cNvPr id="20" name="Text 17"/>
+          <p:cNvSpPr txBox="1"/>
+          <p:nvPr/>
+        </p:nvSpPr>
+        <p:spPr>
+          <a:xfrm>
+            <a:off x="6583680" y="5029200"/>
+            <a:ext cx="3557016" cy="457200"/>
+          </a:xfrm>
+          <a:prstGeom prst="rect">
+            <a:avLst/>
+          </a:prstGeom>
+          <a:noFill/>
+          <a:ln/>
+        </p:spPr>
+        <p:txBody>
+          <a:bodyPr wrap="square" lIns="0" tIns="0" rIns="0" bIns="0" rtlCol="0" anchor="t"/>
+          <a:lstStyle/>
+          <a:p>
+            <a:pPr indent="0" marL="0">
+              <a:buNone/>
+            </a:pPr>
+            <a:r>
+              <a:rPr lang="en-US" sz="1250" dirty="0">
+                <a:solidFill>
+                  <a:srgbClr val="1F2933"/>
+                </a:solidFill>
+                <a:latin typeface="Calibri" pitchFamily="34" charset="0"/>
+                <a:ea typeface="Calibri" pitchFamily="34" charset="-122"/>
+                <a:cs typeface="Calibri" pitchFamily="34" charset="-120"/>
+              </a:rPr>
+              <a:t>In Chrome or Edge. First time: “Add port…” and choose the monitor.</a:t>
+            </a:r>
+            <a:endParaRPr lang="en-US" sz="1250" dirty="0"/>
+          </a:p>
+        </p:txBody>
+      </p:sp>
+      <p:sp>
+        <p:nvSpPr>
+          <p:cNvPr id="21" name="Shape 18"/>
+          <p:cNvSpPr/>
+          <p:nvPr/>
+        </p:nvSpPr>
+        <p:spPr>
+          <a:xfrm>
+            <a:off x="5989320" y="5623560"/>
+            <a:ext cx="420624" cy="420624"/>
+          </a:xfrm>
+          <a:prstGeom prst="ellipse">
+            <a:avLst/>
+          </a:prstGeom>
+          <a:solidFill>
+            <a:srgbClr val="5292BD"/>
+          </a:solidFill>
+          <a:ln w="12700">
+            <a:solidFill>
+              <a:srgbClr val="5292BD"/>
+            </a:solidFill>
+            <a:prstDash val="solid"/>
+          </a:ln>
+        </p:spPr>
+      </p:sp>
+      <p:sp>
+        <p:nvSpPr>
+          <p:cNvPr id="22" name="Text 19"/>
+          <p:cNvSpPr txBox="1"/>
+          <p:nvPr/>
+        </p:nvSpPr>
+        <p:spPr>
+          <a:xfrm>
+            <a:off x="5989320" y="5623560"/>
+            <a:ext cx="420624" cy="420624"/>
+          </a:xfrm>
+          <a:prstGeom prst="rect">
+            <a:avLst/>
+          </a:prstGeom>
+          <a:noFill/>
+          <a:ln/>
+        </p:spPr>
+        <p:txBody>
+          <a:bodyPr wrap="square" lIns="0" tIns="0" rIns="0" bIns="0" rtlCol="0" anchor="ctr"/>
+          <a:lstStyle/>
+          <a:p>
+            <a:pPr algn="ctr" indent="0" marL="0">
+              <a:buNone/>
+            </a:pPr>
+            <a:r>
+              <a:rPr lang="en-US" sz="1196" b="1" dirty="0">
+                <a:solidFill>
+                  <a:srgbClr val="FFFFFF"/>
+                </a:solidFill>
+                <a:latin typeface="Cambria" pitchFamily="34" charset="0"/>
+                <a:ea typeface="Cambria" pitchFamily="34" charset="-122"/>
+                <a:cs typeface="Cambria" pitchFamily="34" charset="-120"/>
+              </a:rPr>
+              <a:t>4</a:t>
+            </a:r>
+            <a:endParaRPr lang="en-US" sz="1196" dirty="0"/>
+          </a:p>
+        </p:txBody>
+      </p:sp>
+      <p:sp>
+        <p:nvSpPr>
+          <p:cNvPr id="23" name="Text 20"/>
+          <p:cNvSpPr txBox="1"/>
+          <p:nvPr/>
+        </p:nvSpPr>
+        <p:spPr>
+          <a:xfrm>
+            <a:off x="6583680" y="5586984"/>
+            <a:ext cx="3557016" cy="310896"/>
+          </a:xfrm>
+          <a:prstGeom prst="rect">
+            <a:avLst/>
+          </a:prstGeom>
+          <a:noFill/>
+          <a:ln/>
+        </p:spPr>
+        <p:txBody>
+          <a:bodyPr wrap="square" lIns="0" tIns="0" rIns="0" bIns="0" rtlCol="0" anchor="ctr"/>
+          <a:lstStyle/>
+          <a:p>
+            <a:pPr indent="0" marL="0">
+              <a:buNone/>
+            </a:pPr>
+            <a:r>
+              <a:rPr lang="en-US" sz="1500" b="1" dirty="0">
+                <a:solidFill>
+                  <a:srgbClr val="184D7B"/>
+                </a:solidFill>
+                <a:latin typeface="Calibri" pitchFamily="34" charset="0"/>
+                <a:ea typeface="Calibri" pitchFamily="34" charset="-122"/>
+                <a:cs typeface="Calibri" pitchFamily="34" charset="-120"/>
+              </a:rPr>
+              <a:t>Connect and record</a:t>
+            </a:r>
+            <a:endParaRPr lang="en-US" sz="1500" dirty="0"/>
+          </a:p>
+        </p:txBody>
+      </p:sp>
+      <p:sp>
+        <p:nvSpPr>
+          <p:cNvPr id="24" name="Text 21"/>
+          <p:cNvSpPr txBox="1"/>
+          <p:nvPr/>
+        </p:nvSpPr>
+        <p:spPr>
+          <a:xfrm>
+            <a:off x="6583680" y="5897880"/>
+            <a:ext cx="3557016" cy="457200"/>
+          </a:xfrm>
+          <a:prstGeom prst="rect">
+            <a:avLst/>
+          </a:prstGeom>
+          <a:noFill/>
+          <a:ln/>
+        </p:spPr>
+        <p:txBody>
+          <a:bodyPr wrap="square" lIns="0" tIns="0" rIns="0" bIns="0" rtlCol="0" anchor="t"/>
+          <a:lstStyle/>
+          <a:p>
+            <a:pPr indent="0" marL="0">
+              <a:buNone/>
+            </a:pPr>
+            <a:r>
+              <a:rPr lang="en-US" sz="1250" dirty="0">
+                <a:solidFill>
+                  <a:srgbClr val="1F2933"/>
+                </a:solidFill>
+                <a:latin typeface="Calibri" pitchFamily="34" charset="0"/>
+                <a:ea typeface="Calibri" pitchFamily="34" charset="-122"/>
+                <a:cs typeface="Calibri" pitchFamily="34" charset="-120"/>
+              </a:rPr>
+              <a:t>Click “Connect selection”. Everything is recorded; “Save CSV” stores it.</a:t>
+            </a:r>
+            <a:endParaRPr lang="en-US" sz="1250" dirty="0"/>
+          </a:p>
+        </p:txBody>
+      </p:sp>
+      <p:sp>
+        <p:nvSpPr>
+          <p:cNvPr id="25" name="Text 22"/>
+          <p:cNvSpPr txBox="1"/>
+          <p:nvPr/>
+        </p:nvSpPr>
+        <p:spPr>
+          <a:xfrm>
+            <a:off x="5989320" y="6492240"/>
+            <a:ext cx="4151376" cy="411480"/>
+          </a:xfrm>
+          <a:prstGeom prst="rect">
+            <a:avLst/>
+          </a:prstGeom>
+          <a:noFill/>
+          <a:ln/>
+        </p:spPr>
+        <p:txBody>
+          <a:bodyPr wrap="square" lIns="0" tIns="0" rIns="0" bIns="0" rtlCol="0" anchor="t"/>
+          <a:lstStyle/>
+          <a:p>
+            <a:pPr indent="0" marL="0">
+              <a:buNone/>
+            </a:pPr>
+            <a:r>
+              <a:rPr lang="en-US" sz="1100" dirty="0">
+                <a:solidFill>
+                  <a:srgbClr val="5B6770"/>
+                </a:solidFill>
+                <a:latin typeface="Calibri" pitchFamily="34" charset="0"/>
+                <a:ea typeface="Calibri" pitchFamily="34" charset="-122"/>
+                <a:cs typeface="Calibri" pitchFamily="34" charset="-120"/>
+              </a:rPr>
+              <a:t>The monitor carries its own copy of this page, so no other files are needed. Start pump and Zero calibration work here too.</a:t>
+            </a:r>
+            <a:endParaRPr lang="en-US" sz="1100" dirty="0"/>
+          </a:p>
+        </p:txBody>
+      </p:sp>
+      <p:sp>
+        <p:nvSpPr>
+          <p:cNvPr id="26" name="Text 23"/>
+          <p:cNvSpPr txBox="1"/>
+          <p:nvPr/>
+        </p:nvSpPr>
+        <p:spPr>
+          <a:xfrm>
+            <a:off x="1079504" y="7150608"/>
+            <a:ext cx="1188720" cy="228600"/>
+          </a:xfrm>
+          <a:prstGeom prst="rect">
+            <a:avLst/>
+          </a:prstGeom>
+          <a:noFill/>
+          <a:ln/>
+        </p:spPr>
+        <p:txBody>
+          <a:bodyPr wrap="square" lIns="0" tIns="0" rIns="0" bIns="0" rtlCol="0" anchor="t"/>
+          <a:lstStyle/>
+          <a:p>
+            <a:pPr indent="0" marL="0">
+              <a:buNone/>
+            </a:pPr>
+            <a:r>
+              <a:rPr lang="en-US" sz="1000" i="1" dirty="0">
+                <a:solidFill>
+                  <a:srgbClr val="1F2933"/>
+                </a:solidFill>
+                <a:latin typeface="Calibri" pitchFamily="34" charset="0"/>
+                <a:ea typeface="Calibri" pitchFamily="34" charset="-122"/>
+                <a:cs typeface="Calibri" pitchFamily="34" charset="-120"/>
+              </a:rPr>
+              <a:t>by Teknosofen</a:t>
+            </a:r>
+            <a:endParaRPr lang="en-US" sz="1000" dirty="0"/>
+          </a:p>
+        </p:txBody>
+      </p:sp>
+      <p:pic>
+        <p:nvPicPr>
+          <p:cNvPr id="27" name="Image 1" descr="Örnhagen logo">    </p:cNvPr>
+          <p:cNvPicPr>
+            <a:picLocks noChangeAspect="1"/>
+          </p:cNvPicPr>
+          <p:nvPr/>
+        </p:nvPicPr>
+        <p:blipFill>
+          <a:blip r:embed="rId2"/>
+          <a:stretch>
+            <a:fillRect/>
+          </a:stretch>
+        </p:blipFill>
+        <p:spPr>
+          <a:xfrm>
+            <a:off x="548640" y="6958584"/>
+            <a:ext cx="393704" cy="420624"/>
+          </a:xfrm>
+          <a:prstGeom prst="rect">
+            <a:avLst/>
+          </a:prstGeom>
+        </p:spPr>
+      </p:pic>
+      <p:sp>
+        <p:nvSpPr>
+          <p:cNvPr id="28" name="Text 24"/>
+          <p:cNvSpPr txBox="1"/>
+          <p:nvPr/>
+        </p:nvSpPr>
+        <p:spPr>
+          <a:xfrm>
+            <a:off x="1975616" y="7150608"/>
+            <a:ext cx="4572000" cy="228600"/>
+          </a:xfrm>
+          <a:prstGeom prst="rect">
+            <a:avLst/>
+          </a:prstGeom>
+          <a:noFill/>
+          <a:ln/>
+        </p:spPr>
+        <p:txBody>
+          <a:bodyPr wrap="square" lIns="0" tIns="0" rIns="0" bIns="0" rtlCol="0" anchor="t"/>
+          <a:lstStyle/>
+          <a:p>
+            <a:pPr indent="0" marL="0">
+              <a:buNone/>
+            </a:pPr>
+            <a:r>
+              <a:rPr lang="en-US" sz="900" dirty="0">
+                <a:solidFill>
+                  <a:srgbClr val="5B6770"/>
+                </a:solidFill>
+                <a:latin typeface="Calibri" pitchFamily="34" charset="0"/>
+                <a:ea typeface="Calibri" pitchFamily="34" charset="-122"/>
+                <a:cs typeface="Calibri" pitchFamily="34" charset="-120"/>
+              </a:rPr>
+              <a:t>·   Eaglehagen CO₂ Monitor  ·  Basic setup</a:t>
+            </a:r>
+            <a:endParaRPr lang="en-US" sz="900" dirty="0"/>
+          </a:p>
+        </p:txBody>
+      </p:sp>
+      <p:sp>
+        <p:nvSpPr>
+          <p:cNvPr id="29" name="Text 25"/>
+          <p:cNvSpPr txBox="1"/>
+          <p:nvPr/>
+        </p:nvSpPr>
+        <p:spPr>
+          <a:xfrm>
+            <a:off x="9226296" y="7150608"/>
+            <a:ext cx="914400" cy="228600"/>
+          </a:xfrm>
+          <a:prstGeom prst="rect">
+            <a:avLst/>
+          </a:prstGeom>
+          <a:noFill/>
+          <a:ln/>
+        </p:spPr>
+        <p:txBody>
+          <a:bodyPr wrap="square" lIns="0" tIns="0" rIns="0" bIns="0" rtlCol="0" anchor="t"/>
+          <a:lstStyle/>
+          <a:p>
+            <a:pPr algn="r" indent="0" marL="0">
+              <a:buNone/>
+            </a:pPr>
+            <a:r>
+              <a:rPr lang="en-US" sz="900" dirty="0">
+                <a:solidFill>
+                  <a:srgbClr val="5B6770"/>
+                </a:solidFill>
+                <a:latin typeface="Calibri" pitchFamily="34" charset="0"/>
+                <a:ea typeface="Calibri" pitchFamily="34" charset="-122"/>
+                <a:cs typeface="Calibri" pitchFamily="34" charset="-120"/>
+              </a:rPr>
+              <a:t>7</a:t>
+            </a:r>
+            <a:endParaRPr lang="en-US" sz="900" dirty="0"/>
+          </a:p>
+        </p:txBody>
+      </p:sp>
+    </p:spTree>
+  </p:cSld>
+  <p:clrMapOvr>
+    <a:masterClrMapping/>
+  </p:clrMapOvr>
+</p:sld>
+</file>
+
+<file path=ppt/slides/slide8.xml><?xml version="1.0" encoding="utf-8"?>
+<p:sld xmlns:a="http://schemas.openxmlformats.org/drawingml/2006/main" xmlns:r="http://schemas.openxmlformats.org/officeDocument/2006/relationships" xmlns:p="http://schemas.openxmlformats.org/presentationml/2006/main">
+  <p:cSld name="Slide 8">
+    <p:bg>
+      <p:bgPr>
+        <a:solidFill>
+          <a:srgbClr val="FFFFFF"/>
+        </a:solidFill>
+      </p:bgPr>
+    </p:bg>
+    <p:spTree>
+      <p:nvGrpSpPr>
+        <p:cNvPr id="1" name=""/>
+        <p:cNvGrpSpPr/>
+        <p:nvPr/>
+      </p:nvGrpSpPr>
+      <p:grpSpPr>
+        <a:xfrm>
+          <a:off x="0" y="0"/>
+          <a:ext cx="0" cy="0"/>
+          <a:chOff x="0" y="0"/>
+          <a:chExt cx="0" cy="0"/>
+        </a:xfrm>
+      </p:grpSpPr>
+      <p:sp>
+        <p:nvSpPr>
+          <p:cNvPr id="2" name="Text 0"/>
+          <p:cNvSpPr txBox="1"/>
+          <p:nvPr/>
+        </p:nvSpPr>
+        <p:spPr>
+          <a:xfrm>
+            <a:off x="548640" y="411480"/>
+            <a:ext cx="9592056" cy="640080"/>
+          </a:xfrm>
+          <a:prstGeom prst="rect">
+            <a:avLst/>
+          </a:prstGeom>
+          <a:noFill/>
+          <a:ln/>
+        </p:spPr>
+        <p:txBody>
+          <a:bodyPr wrap="square" lIns="0" tIns="0" rIns="0" bIns="0" rtlCol="0" anchor="ctr"/>
+          <a:lstStyle/>
+          <a:p>
+            <a:pPr indent="0" marL="0">
+              <a:buNone/>
+            </a:pPr>
+            <a:r>
+              <a:rPr lang="en-US" sz="3200" b="1" dirty="0">
+                <a:solidFill>
+                  <a:srgbClr val="184D7B"/>
+                </a:solidFill>
+                <a:latin typeface="Cambria" pitchFamily="34" charset="0"/>
+                <a:ea typeface="Cambria" pitchFamily="34" charset="-122"/>
+                <a:cs typeface="Cambria" pitchFamily="34" charset="-120"/>
+              </a:rPr>
+              <a:t>If something is wrong</a:t>
+            </a:r>
+            <a:endParaRPr lang="en-US" sz="3200" dirty="0"/>
+          </a:p>
+        </p:txBody>
+      </p:sp>
+      <p:sp>
+        <p:nvSpPr>
+          <p:cNvPr id="3" name="Text 1"/>
+          <p:cNvSpPr txBox="1"/>
+          <p:nvPr/>
+        </p:nvSpPr>
+        <p:spPr>
+          <a:xfrm>
+            <a:off x="548640" y="1024128"/>
+            <a:ext cx="9592056" cy="365760"/>
+          </a:xfrm>
+          <a:prstGeom prst="rect">
+            <a:avLst/>
+          </a:prstGeom>
+          <a:noFill/>
+          <a:ln/>
+        </p:spPr>
+        <p:txBody>
+          <a:bodyPr wrap="square" lIns="0" tIns="0" rIns="0" bIns="0" rtlCol="0" anchor="ctr"/>
+          <a:lstStyle/>
+          <a:p>
+            <a:pPr indent="0" marL="0">
+              <a:buNone/>
+            </a:pPr>
+            <a:r>
+              <a:rPr lang="en-US" sz="1500" dirty="0">
+                <a:solidFill>
+                  <a:srgbClr val="5B6770"/>
+                </a:solidFill>
+                <a:latin typeface="Calibri" pitchFamily="34" charset="0"/>
+                <a:ea typeface="Calibri" pitchFamily="34" charset="-122"/>
+                <a:cs typeface="Calibri" pitchFamily="34" charset="-120"/>
+              </a:rPr>
               <a:t>The most common situations and what to do</a:t>
             </a:r>
             <a:endParaRPr lang="en-US" sz="1500" dirty="0"/>
@@ -11423,7 +12752,7 @@
       </p:sp>
       <p:graphicFrame>
         <p:nvGraphicFramePr>
-          <p:cNvPr id="8" name="Table 0"/>
+          <p:cNvPr id="9" name="Table 0"/>
           <p:cNvGraphicFramePr>
             <a:graphicFrameLocks noGrp="1"/>
           </p:cNvGraphicFramePr>
@@ -11447,7 +12776,7 @@
                 <a:gridCol w="3108960"/>
                 <a:gridCol w="6483096"/>
               </a:tblGrid>
-              <a:tr h="502920">
+              <a:tr h="475488">
                 <a:tc>
                   <a:txBody>
                     <a:bodyPr/>
@@ -11585,7 +12914,7 @@
                   </a:tcPr>
                 </a:tc>
               </a:tr>
-              <a:tr h="502920">
+              <a:tr h="475488">
                 <a:tc>
                   <a:txBody>
                     <a:bodyPr/>
@@ -11723,7 +13052,7 @@
                   </a:tcPr>
                 </a:tc>
               </a:tr>
-              <a:tr h="502920">
+              <a:tr h="475488">
                 <a:tc>
                   <a:txBody>
                     <a:bodyPr/>
@@ -11861,7 +13190,7 @@
                   </a:tcPr>
                 </a:tc>
               </a:tr>
-              <a:tr h="502920">
+              <a:tr h="475488">
                 <a:tc>
                   <a:txBody>
                     <a:bodyPr/>
@@ -11999,7 +13328,7 @@
                   </a:tcPr>
                 </a:tc>
               </a:tr>
-              <a:tr h="502920">
+              <a:tr h="475488">
                 <a:tc>
                   <a:txBody>
                     <a:bodyPr/>
@@ -12137,7 +13466,7 @@
                   </a:tcPr>
                 </a:tc>
               </a:tr>
-              <a:tr h="502920">
+              <a:tr h="475488">
                 <a:tc>
                   <a:txBody>
                     <a:bodyPr/>
@@ -12275,7 +13604,7 @@
                   </a:tcPr>
                 </a:tc>
               </a:tr>
-              <a:tr h="502920">
+              <a:tr h="475488">
                 <a:tc>
                   <a:txBody>
                     <a:bodyPr/>
@@ -12413,7 +13742,7 @@
                   </a:tcPr>
                 </a:tc>
               </a:tr>
-              <a:tr h="502920">
+              <a:tr h="475488">
                 <a:tc>
                   <a:txBody>
                     <a:bodyPr/>
@@ -12551,7 +13880,7 @@
                   </a:tcPr>
                 </a:tc>
               </a:tr>
-              <a:tr h="502920">
+              <a:tr h="475488">
                 <a:tc>
                   <a:txBody>
                     <a:bodyPr/>
@@ -12689,13 +14018,190 @@
                   </a:tcPr>
                 </a:tc>
               </a:tr>
+              <a:tr h="475488">
+                <a:tc>
+                  <a:txBody>
+                    <a:bodyPr/>
+                    <a:lstStyle/>
+                    <a:p>
+                      <a:pPr indent="0" marL="0">
+                        <a:buNone/>
+                      </a:pPr>
+                      <a:r>
+                        <a:rPr lang="en-US" sz="1300" b="1" dirty="0">
+                          <a:solidFill>
+                            <a:srgbClr val="184D7B"/>
+                          </a:solidFill>
+                          <a:latin typeface="Calibri" pitchFamily="34" charset="0"/>
+                          <a:ea typeface="Calibri" pitchFamily="34" charset="-122"/>
+                          <a:cs typeface="Calibri" pitchFamily="34" charset="-120"/>
+                        </a:rPr>
+                        <a:t>PC monitor page cannot connect</a:t>
+                      </a:r>
+                      <a:endParaRPr lang="en-US" sz="1300" dirty="0">
+                        <a:latin typeface="Calibri" charset="0"/>
+                        <a:ea typeface="Calibri" charset="0"/>
+                        <a:cs typeface="Calibri" charset="0"/>
+                      </a:endParaRPr>
+                    </a:p>
+                  </a:txBody>
+                  <a:tcPr marL="109728" marR="109728" marT="54864" marB="54864" anchor="ctr">
+                    <a:lnL w="6350" cap="flat" cmpd="sng" algn="ctr">
+                      <a:solidFill>
+                        <a:srgbClr val="CBD5DF"/>
+                      </a:solidFill>
+                      <a:prstDash val="solid"/>
+                      <a:round/>
+                      <a:headEnd type="none" w="med" len="med"/>
+                      <a:tailEnd type="none" w="med" len="med"/>
+                    </a:lnL>
+                    <a:lnR w="6350" cap="flat" cmpd="sng" algn="ctr">
+                      <a:solidFill>
+                        <a:srgbClr val="CBD5DF"/>
+                      </a:solidFill>
+                      <a:prstDash val="solid"/>
+                      <a:round/>
+                      <a:headEnd type="none" w="med" len="med"/>
+                      <a:tailEnd type="none" w="med" len="med"/>
+                    </a:lnR>
+                    <a:lnT w="6350" cap="flat" cmpd="sng" algn="ctr">
+                      <a:solidFill>
+                        <a:srgbClr val="CBD5DF"/>
+                      </a:solidFill>
+                      <a:prstDash val="solid"/>
+                      <a:round/>
+                      <a:headEnd type="none" w="med" len="med"/>
+                      <a:tailEnd type="none" w="med" len="med"/>
+                    </a:lnT>
+                    <a:lnB w="6350" cap="flat" cmpd="sng" algn="ctr">
+                      <a:solidFill>
+                        <a:srgbClr val="CBD5DF"/>
+                      </a:solidFill>
+                      <a:prstDash val="solid"/>
+                      <a:round/>
+                      <a:headEnd type="none" w="med" len="med"/>
+                      <a:tailEnd type="none" w="med" len="med"/>
+                    </a:lnB>
+                    <a:solidFill>
+                      <a:srgbClr val="E8F1F8"/>
+                    </a:solidFill>
+                  </a:tcPr>
+                </a:tc>
+                <a:tc>
+                  <a:txBody>
+                    <a:bodyPr/>
+                    <a:lstStyle/>
+                    <a:p>
+                      <a:pPr indent="0" marL="0">
+                        <a:buNone/>
+                      </a:pPr>
+                      <a:r>
+                        <a:rPr lang="en-US" sz="1300" dirty="0">
+                          <a:solidFill>
+                            <a:srgbClr val="1F2933"/>
+                          </a:solidFill>
+                          <a:latin typeface="Calibri" pitchFamily="34" charset="0"/>
+                          <a:ea typeface="Calibri" pitchFamily="34" charset="-122"/>
+                          <a:cs typeface="Calibri" pitchFamily="34" charset="-120"/>
+                        </a:rPr>
+                        <a:t>Close LabVIEW (only one program per port). Use Chrome or Edge.</a:t>
+                      </a:r>
+                      <a:endParaRPr lang="en-US" sz="1300" dirty="0">
+                        <a:latin typeface="Calibri" charset="0"/>
+                        <a:ea typeface="Calibri" charset="0"/>
+                        <a:cs typeface="Calibri" charset="0"/>
+                      </a:endParaRPr>
+                    </a:p>
+                  </a:txBody>
+                  <a:tcPr marL="109728" marR="109728" marT="54864" marB="54864" anchor="ctr">
+                    <a:lnL w="6350" cap="flat" cmpd="sng" algn="ctr">
+                      <a:solidFill>
+                        <a:srgbClr val="CBD5DF"/>
+                      </a:solidFill>
+                      <a:prstDash val="solid"/>
+                      <a:round/>
+                      <a:headEnd type="none" w="med" len="med"/>
+                      <a:tailEnd type="none" w="med" len="med"/>
+                    </a:lnL>
+                    <a:lnR w="6350" cap="flat" cmpd="sng" algn="ctr">
+                      <a:solidFill>
+                        <a:srgbClr val="CBD5DF"/>
+                      </a:solidFill>
+                      <a:prstDash val="solid"/>
+                      <a:round/>
+                      <a:headEnd type="none" w="med" len="med"/>
+                      <a:tailEnd type="none" w="med" len="med"/>
+                    </a:lnR>
+                    <a:lnT w="6350" cap="flat" cmpd="sng" algn="ctr">
+                      <a:solidFill>
+                        <a:srgbClr val="CBD5DF"/>
+                      </a:solidFill>
+                      <a:prstDash val="solid"/>
+                      <a:round/>
+                      <a:headEnd type="none" w="med" len="med"/>
+                      <a:tailEnd type="none" w="med" len="med"/>
+                    </a:lnT>
+                    <a:lnB w="6350" cap="flat" cmpd="sng" algn="ctr">
+                      <a:solidFill>
+                        <a:srgbClr val="CBD5DF"/>
+                      </a:solidFill>
+                      <a:prstDash val="solid"/>
+                      <a:round/>
+                      <a:headEnd type="none" w="med" len="med"/>
+                      <a:tailEnd type="none" w="med" len="med"/>
+                    </a:lnB>
+                    <a:solidFill>
+                      <a:srgbClr val="E8F1F8"/>
+                    </a:solidFill>
+                  </a:tcPr>
+                </a:tc>
+              </a:tr>
             </a:tbl>
           </a:graphicData>
         </a:graphic>
       </p:graphicFrame>
+      <p:sp>
+        <p:nvSpPr>
+          <p:cNvPr id="5" name="Text 2"/>
+          <p:cNvSpPr txBox="1"/>
+          <p:nvPr/>
+        </p:nvSpPr>
+        <p:spPr>
+          <a:xfrm>
+            <a:off x="1079504" y="7150608"/>
+            <a:ext cx="1188720" cy="228600"/>
+          </a:xfrm>
+          <a:prstGeom prst="rect">
+            <a:avLst/>
+          </a:prstGeom>
+          <a:noFill/>
+          <a:ln/>
+        </p:spPr>
+        <p:txBody>
+          <a:bodyPr wrap="square" lIns="0" tIns="0" rIns="0" bIns="0" rtlCol="0" anchor="t"/>
+          <a:lstStyle/>
+          <a:p>
+            <a:pPr indent="0" marL="0">
+              <a:buNone/>
+            </a:pPr>
+            <a:r>
+              <a:rPr lang="en-US" sz="1000" i="1" dirty="0">
+                <a:solidFill>
+                  <a:srgbClr val="1F2933"/>
+                </a:solidFill>
+                <a:latin typeface="Calibri" pitchFamily="34" charset="0"/>
+                <a:ea typeface="Calibri" pitchFamily="34" charset="-122"/>
+                <a:cs typeface="Calibri" pitchFamily="34" charset="-120"/>
+              </a:rPr>
+              <a:t>by Teknosofen</a:t>
+            </a:r>
+            <a:endParaRPr lang="en-US" sz="1000" dirty="0"/>
+          </a:p>
+        </p:txBody>
+      </p:sp>
       <p:pic>
         <p:nvPicPr>
-          <p:cNvPr id="5" name="Image 0" descr="Örnhagen logo">    </p:cNvPr>
+          <p:cNvPr id="6" name="Image 0" descr="Örnhagen logo">    </p:cNvPr>
           <p:cNvPicPr>
             <a:picLocks noChangeAspect="1"/>
           </p:cNvPicPr>
@@ -12719,14 +14225,14 @@
       </p:pic>
       <p:sp>
         <p:nvSpPr>
-          <p:cNvPr id="6" name="Text 2"/>
-          <p:cNvSpPr txBox="1"/>
-          <p:nvPr/>
-        </p:nvSpPr>
-        <p:spPr>
-          <a:xfrm>
-            <a:off x="1079504" y="7150608"/>
-            <a:ext cx="5486400" cy="228600"/>
+          <p:cNvPr id="7" name="Text 3"/>
+          <p:cNvSpPr txBox="1"/>
+          <p:nvPr/>
+        </p:nvSpPr>
+        <p:spPr>
+          <a:xfrm>
+            <a:off x="1975616" y="7150608"/>
+            <a:ext cx="4572000" cy="228600"/>
           </a:xfrm>
           <a:prstGeom prst="rect">
             <a:avLst/>
@@ -12750,7 +14256,7 @@
                 <a:ea typeface="Calibri" pitchFamily="34" charset="-122"/>
                 <a:cs typeface="Calibri" pitchFamily="34" charset="-120"/>
               </a:rPr>
-              <a:t>Eaglehagen CO₂ Monitor  ·  Basic setup</a:t>
+              <a:t>·   Eaglehagen CO₂ Monitor  ·  Basic setup</a:t>
             </a:r>
             <a:endParaRPr lang="en-US" sz="900" dirty="0"/>
           </a:p>
@@ -12758,7 +14264,7 @@
       </p:sp>
       <p:sp>
         <p:nvSpPr>
-          <p:cNvPr id="7" name="Text 3"/>
+          <p:cNvPr id="8" name="Text 4"/>
           <p:cNvSpPr txBox="1"/>
           <p:nvPr/>
         </p:nvSpPr>
@@ -12789,7 +14295,7 @@
                 <a:ea typeface="Calibri" pitchFamily="34" charset="-122"/>
                 <a:cs typeface="Calibri" pitchFamily="34" charset="-120"/>
               </a:rPr>
-              <a:t>7</a:t>
+              <a:t>8</a:t>
             </a:r>
             <a:endParaRPr lang="en-US" sz="900" dirty="0"/>
           </a:p>
@@ -12803,9 +14309,9 @@
 </p:sld>
 </file>
 
-<file path=ppt/slides/slide8.xml><?xml version="1.0" encoding="utf-8"?>
+<file path=ppt/slides/slide9.xml><?xml version="1.0" encoding="utf-8"?>
 <p:sld xmlns:a="http://schemas.openxmlformats.org/drawingml/2006/main" xmlns:r="http://schemas.openxmlformats.org/officeDocument/2006/relationships" xmlns:p="http://schemas.openxmlformats.org/presentationml/2006/main">
-  <p:cSld name="Slide 8">
+  <p:cSld name="Slide 9">
     <p:bg>
       <p:bgPr>
         <a:solidFill>
@@ -14051,15 +15557,54 @@
                 <a:ea typeface="Calibri" pitchFamily="34" charset="-122"/>
                 <a:cs typeface="Calibri" pitchFamily="34" charset="-120"/>
               </a:rPr>
-              <a:t>save as CSV or JSON</a:t>
+              <a:t>longer: PC monitor page</a:t>
             </a:r>
             <a:endParaRPr lang="en-US" sz="1200" dirty="0"/>
+          </a:p>
+        </p:txBody>
+      </p:sp>
+      <p:sp>
+        <p:nvSpPr>
+          <p:cNvPr id="36" name="Text 34"/>
+          <p:cNvSpPr txBox="1"/>
+          <p:nvPr/>
+        </p:nvSpPr>
+        <p:spPr>
+          <a:xfrm>
+            <a:off x="1079504" y="7150608"/>
+            <a:ext cx="1188720" cy="228600"/>
+          </a:xfrm>
+          <a:prstGeom prst="rect">
+            <a:avLst/>
+          </a:prstGeom>
+          <a:noFill/>
+          <a:ln/>
+        </p:spPr>
+        <p:txBody>
+          <a:bodyPr wrap="square" lIns="0" tIns="0" rIns="0" bIns="0" rtlCol="0" anchor="t"/>
+          <a:lstStyle/>
+          <a:p>
+            <a:pPr indent="0" marL="0">
+              <a:buNone/>
+            </a:pPr>
+            <a:r>
+              <a:rPr lang="en-US" sz="1000" i="1" dirty="0">
+                <a:solidFill>
+                  <a:srgbClr val="1F2933"/>
+                </a:solidFill>
+                <a:latin typeface="Calibri" pitchFamily="34" charset="0"/>
+                <a:ea typeface="Calibri" pitchFamily="34" charset="-122"/>
+                <a:cs typeface="Calibri" pitchFamily="34" charset="-120"/>
+              </a:rPr>
+              <a:t>by Teknosofen</a:t>
+            </a:r>
+            <a:endParaRPr lang="en-US" sz="1000" dirty="0"/>
           </a:p>
         </p:txBody>
       </p:sp>
       <p:pic>
         <p:nvPicPr>
-          <p:cNvPr id="36" name="Image 0" descr="Örnhagen logo">    </p:cNvPr>
+          <p:cNvPr id="37" name="Image 0" descr="Örnhagen logo">    </p:cNvPr>
           <p:cNvPicPr>
             <a:picLocks noChangeAspect="1"/>
           </p:cNvPicPr>
@@ -14083,14 +15628,14 @@
       </p:pic>
       <p:sp>
         <p:nvSpPr>
-          <p:cNvPr id="37" name="Text 34"/>
-          <p:cNvSpPr txBox="1"/>
-          <p:nvPr/>
-        </p:nvSpPr>
-        <p:spPr>
-          <a:xfrm>
-            <a:off x="1079504" y="7150608"/>
-            <a:ext cx="5486400" cy="228600"/>
+          <p:cNvPr id="38" name="Text 35"/>
+          <p:cNvSpPr txBox="1"/>
+          <p:nvPr/>
+        </p:nvSpPr>
+        <p:spPr>
+          <a:xfrm>
+            <a:off x="1975616" y="7150608"/>
+            <a:ext cx="4572000" cy="228600"/>
           </a:xfrm>
           <a:prstGeom prst="rect">
             <a:avLst/>
@@ -14114,7 +15659,7 @@
                 <a:ea typeface="Calibri" pitchFamily="34" charset="-122"/>
                 <a:cs typeface="Calibri" pitchFamily="34" charset="-120"/>
               </a:rPr>
-              <a:t>Eaglehagen CO₂ Monitor  ·  Basic setup</a:t>
+              <a:t>·   Eaglehagen CO₂ Monitor  ·  Basic setup</a:t>
             </a:r>
             <a:endParaRPr lang="en-US" sz="900" dirty="0"/>
           </a:p>
@@ -14122,7 +15667,7 @@
       </p:sp>
       <p:sp>
         <p:nvSpPr>
-          <p:cNvPr id="38" name="Text 35"/>
+          <p:cNvPr id="39" name="Text 36"/>
           <p:cNvSpPr txBox="1"/>
           <p:nvPr/>
         </p:nvSpPr>
@@ -14153,7 +15698,7 @@
                 <a:ea typeface="Calibri" pitchFamily="34" charset="-122"/>
                 <a:cs typeface="Calibri" pitchFamily="34" charset="-120"/>
               </a:rPr>
-              <a:t>8</a:t>
+              <a:t>9</a:t>
             </a:r>
             <a:endParaRPr lang="en-US" sz="900" dirty="0"/>
           </a:p>

</xml_diff>

<commit_message>
Point all documentation to the public GitHub repository
Add https://github.com/Teknosofen/EagleHagen to the user guide (intro
and quick reference), the design reference, the README and the setup
handout (title page and quick reference). README also lists the
handout.

Co-Authored-By: Claude Opus 5.5 <noreply@anthropic.com>
</commit_message>
<xml_diff>
--- a/documentation/Eaglehagen_Basic_Setup.pptx
+++ b/documentation/Eaglehagen_Basic_Setup.pptx
@@ -1762,7 +1762,67 @@
       </p:sp>
       <p:sp>
         <p:nvSpPr>
-          <p:cNvPr id="6" name="Shape 4"/>
+          <p:cNvPr id="6" name="Text 4"/>
+          <p:cNvSpPr txBox="1"/>
+          <p:nvPr/>
+        </p:nvSpPr>
+        <p:spPr>
+          <a:xfrm>
+            <a:off x="548640" y="5486400"/>
+            <a:ext cx="6035040" cy="320040"/>
+          </a:xfrm>
+          <a:prstGeom prst="rect">
+            <a:avLst/>
+          </a:prstGeom>
+          <a:noFill/>
+          <a:ln/>
+        </p:spPr>
+        <p:txBody>
+          <a:bodyPr wrap="square" lIns="0" tIns="0" rIns="0" bIns="0" rtlCol="0" anchor="t"/>
+          <a:lstStyle/>
+          <a:p>
+            <a:pPr indent="0" marL="0">
+              <a:buNone/>
+            </a:pPr>
+            <a:r>
+              <a:rPr lang="en-US" sz="1400" dirty="0">
+                <a:solidFill>
+                  <a:srgbClr val="5B6770"/>
+                </a:solidFill>
+                <a:latin typeface="Calibri" pitchFamily="34" charset="0"/>
+                <a:ea typeface="Calibri" pitchFamily="34" charset="-122"/>
+                <a:cs typeface="Calibri" pitchFamily="34" charset="-120"/>
+              </a:rPr>
+              <a:t>All documentation: </a:t>
+            </a:r>
+            <a:pPr indent="0" marL="0">
+              <a:buNone/>
+            </a:pPr>
+            <a:r>
+              <a:rPr lang="en-US" sz="1400" b="1" u="sng" dirty="0">
+                <a:solidFill>
+                  <a:srgbClr val="184D7B"/>
+                </a:solidFill>
+                <a:latin typeface="Calibri" pitchFamily="34" charset="0"/>
+                <a:ea typeface="Calibri" pitchFamily="34" charset="-122"/>
+                <a:cs typeface="Calibri" pitchFamily="34" charset="-120"/>
+                <a:hlinkClick r:id="rId1" invalidUrl="" action="" tgtFrame="" tooltip="" history="1" highlightClick="0" endSnd="0">
+                  <a:extLst>
+                    <a:ext uri="{A12FA001-AC4F-418D-AE19-62706E023703}">
+                      <ahyp:hlinkClr xmlns:ahyp="http://schemas.microsoft.com/office/drawing/2018/hyperlinkcolor" val="tx"/>
+                    </a:ext>
+                  </a:extLst>
+                </a:hlinkClick>
+              </a:rPr>
+              <a:t>github.com/Teknosofen/EagleHagen</a:t>
+            </a:r>
+            <a:endParaRPr lang="en-US" sz="1400" dirty="0"/>
+          </a:p>
+        </p:txBody>
+      </p:sp>
+      <p:sp>
+        <p:nvSpPr>
+          <p:cNvPr id="7" name="Shape 5"/>
           <p:cNvSpPr/>
           <p:nvPr/>
         </p:nvSpPr>
@@ -1789,7 +1849,7 @@
       </p:sp>
       <p:sp>
         <p:nvSpPr>
-          <p:cNvPr id="7" name="Shape 5"/>
+          <p:cNvPr id="8" name="Shape 6"/>
           <p:cNvSpPr/>
           <p:nvPr/>
         </p:nvSpPr>
@@ -1814,7 +1874,7 @@
       </p:sp>
       <p:sp>
         <p:nvSpPr>
-          <p:cNvPr id="8" name="Text 6"/>
+          <p:cNvPr id="9" name="Text 7"/>
           <p:cNvSpPr txBox="1"/>
           <p:nvPr/>
         </p:nvSpPr>
@@ -1853,7 +1913,7 @@
       </p:sp>
       <p:sp>
         <p:nvSpPr>
-          <p:cNvPr id="9" name="Shape 7"/>
+          <p:cNvPr id="10" name="Shape 8"/>
           <p:cNvSpPr/>
           <p:nvPr/>
         </p:nvSpPr>
@@ -1878,7 +1938,7 @@
       </p:sp>
       <p:sp>
         <p:nvSpPr>
-          <p:cNvPr id="10" name="Shape 8"/>
+          <p:cNvPr id="11" name="Shape 9"/>
           <p:cNvSpPr/>
           <p:nvPr/>
         </p:nvSpPr>
@@ -1903,7 +1963,7 @@
       </p:sp>
       <p:sp>
         <p:nvSpPr>
-          <p:cNvPr id="11" name="Shape 9"/>
+          <p:cNvPr id="12" name="Shape 10"/>
           <p:cNvSpPr/>
           <p:nvPr/>
         </p:nvSpPr>
@@ -1926,7 +1986,7 @@
       </p:sp>
       <p:sp>
         <p:nvSpPr>
-          <p:cNvPr id="12" name="Shape 10"/>
+          <p:cNvPr id="13" name="Shape 11"/>
           <p:cNvSpPr/>
           <p:nvPr/>
         </p:nvSpPr>
@@ -1949,7 +2009,7 @@
       </p:sp>
       <p:sp>
         <p:nvSpPr>
-          <p:cNvPr id="13" name="Shape 11"/>
+          <p:cNvPr id="14" name="Shape 12"/>
           <p:cNvSpPr/>
           <p:nvPr/>
         </p:nvSpPr>
@@ -1972,7 +2032,7 @@
       </p:sp>
       <p:sp>
         <p:nvSpPr>
-          <p:cNvPr id="14" name="Shape 12"/>
+          <p:cNvPr id="15" name="Shape 13"/>
           <p:cNvSpPr/>
           <p:nvPr/>
         </p:nvSpPr>
@@ -1995,7 +2055,7 @@
       </p:sp>
       <p:sp>
         <p:nvSpPr>
-          <p:cNvPr id="15" name="Shape 13"/>
+          <p:cNvPr id="16" name="Shape 14"/>
           <p:cNvSpPr/>
           <p:nvPr/>
         </p:nvSpPr>
@@ -2018,7 +2078,7 @@
       </p:sp>
       <p:sp>
         <p:nvSpPr>
-          <p:cNvPr id="16" name="Shape 14"/>
+          <p:cNvPr id="17" name="Shape 15"/>
           <p:cNvSpPr/>
           <p:nvPr/>
         </p:nvSpPr>
@@ -2041,7 +2101,7 @@
       </p:sp>
       <p:sp>
         <p:nvSpPr>
-          <p:cNvPr id="17" name="Shape 15"/>
+          <p:cNvPr id="18" name="Shape 16"/>
           <p:cNvSpPr/>
           <p:nvPr/>
         </p:nvSpPr>
@@ -2064,7 +2124,7 @@
       </p:sp>
       <p:sp>
         <p:nvSpPr>
-          <p:cNvPr id="18" name="Shape 16"/>
+          <p:cNvPr id="19" name="Shape 17"/>
           <p:cNvSpPr/>
           <p:nvPr/>
         </p:nvSpPr>
@@ -2087,7 +2147,7 @@
       </p:sp>
       <p:sp>
         <p:nvSpPr>
-          <p:cNvPr id="19" name="Shape 17"/>
+          <p:cNvPr id="20" name="Shape 18"/>
           <p:cNvSpPr/>
           <p:nvPr/>
         </p:nvSpPr>
@@ -2110,7 +2170,7 @@
       </p:sp>
       <p:sp>
         <p:nvSpPr>
-          <p:cNvPr id="20" name="Shape 18"/>
+          <p:cNvPr id="21" name="Shape 19"/>
           <p:cNvSpPr/>
           <p:nvPr/>
         </p:nvSpPr>
@@ -2133,7 +2193,7 @@
       </p:sp>
       <p:sp>
         <p:nvSpPr>
-          <p:cNvPr id="21" name="Shape 19"/>
+          <p:cNvPr id="22" name="Shape 20"/>
           <p:cNvSpPr/>
           <p:nvPr/>
         </p:nvSpPr>
@@ -2156,7 +2216,7 @@
       </p:sp>
       <p:sp>
         <p:nvSpPr>
-          <p:cNvPr id="22" name="Shape 20"/>
+          <p:cNvPr id="23" name="Shape 21"/>
           <p:cNvSpPr/>
           <p:nvPr/>
         </p:nvSpPr>
@@ -2179,7 +2239,7 @@
       </p:sp>
       <p:sp>
         <p:nvSpPr>
-          <p:cNvPr id="23" name="Shape 21"/>
+          <p:cNvPr id="24" name="Shape 22"/>
           <p:cNvSpPr/>
           <p:nvPr/>
         </p:nvSpPr>
@@ -2202,7 +2262,7 @@
       </p:sp>
       <p:sp>
         <p:nvSpPr>
-          <p:cNvPr id="24" name="Shape 22"/>
+          <p:cNvPr id="25" name="Shape 23"/>
           <p:cNvSpPr/>
           <p:nvPr/>
         </p:nvSpPr>
@@ -2225,7 +2285,7 @@
       </p:sp>
       <p:sp>
         <p:nvSpPr>
-          <p:cNvPr id="25" name="Shape 23"/>
+          <p:cNvPr id="26" name="Shape 24"/>
           <p:cNvSpPr/>
           <p:nvPr/>
         </p:nvSpPr>
@@ -2248,7 +2308,7 @@
       </p:sp>
       <p:sp>
         <p:nvSpPr>
-          <p:cNvPr id="26" name="Text 24"/>
+          <p:cNvPr id="27" name="Text 25"/>
           <p:cNvSpPr txBox="1"/>
           <p:nvPr/>
         </p:nvSpPr>
@@ -2287,7 +2347,7 @@
       </p:sp>
       <p:sp>
         <p:nvSpPr>
-          <p:cNvPr id="27" name="Shape 25"/>
+          <p:cNvPr id="28" name="Shape 26"/>
           <p:cNvSpPr/>
           <p:nvPr/>
         </p:nvSpPr>
@@ -2314,7 +2374,7 @@
       </p:sp>
       <p:sp>
         <p:nvSpPr>
-          <p:cNvPr id="28" name="Text 26"/>
+          <p:cNvPr id="29" name="Text 27"/>
           <p:cNvSpPr txBox="1"/>
           <p:nvPr/>
         </p:nvSpPr>
@@ -2353,7 +2413,7 @@
       </p:sp>
       <p:sp>
         <p:nvSpPr>
-          <p:cNvPr id="29" name="Text 27"/>
+          <p:cNvPr id="30" name="Text 28"/>
           <p:cNvSpPr txBox="1"/>
           <p:nvPr/>
         </p:nvSpPr>
@@ -2392,7 +2452,7 @@
       </p:sp>
       <p:sp>
         <p:nvSpPr>
-          <p:cNvPr id="30" name="Text 28"/>
+          <p:cNvPr id="31" name="Text 29"/>
           <p:cNvSpPr txBox="1"/>
           <p:nvPr/>
         </p:nvSpPr>
@@ -2431,7 +2491,7 @@
       </p:sp>
       <p:sp>
         <p:nvSpPr>
-          <p:cNvPr id="31" name="Shape 29"/>
+          <p:cNvPr id="32" name="Shape 30"/>
           <p:cNvSpPr/>
           <p:nvPr/>
         </p:nvSpPr>
@@ -2458,7 +2518,7 @@
       </p:sp>
       <p:sp>
         <p:nvSpPr>
-          <p:cNvPr id="32" name="Text 30"/>
+          <p:cNvPr id="33" name="Text 31"/>
           <p:cNvSpPr txBox="1"/>
           <p:nvPr/>
         </p:nvSpPr>
@@ -2497,7 +2557,7 @@
       </p:sp>
       <p:sp>
         <p:nvSpPr>
-          <p:cNvPr id="33" name="Text 31"/>
+          <p:cNvPr id="34" name="Text 32"/>
           <p:cNvSpPr txBox="1"/>
           <p:nvPr/>
         </p:nvSpPr>
@@ -2536,7 +2596,7 @@
       </p:sp>
       <p:sp>
         <p:nvSpPr>
-          <p:cNvPr id="34" name="Text 32"/>
+          <p:cNvPr id="35" name="Text 33"/>
           <p:cNvSpPr txBox="1"/>
           <p:nvPr/>
         </p:nvSpPr>
@@ -2575,7 +2635,7 @@
       </p:sp>
       <p:sp>
         <p:nvSpPr>
-          <p:cNvPr id="35" name="Shape 33"/>
+          <p:cNvPr id="36" name="Shape 34"/>
           <p:cNvSpPr/>
           <p:nvPr/>
         </p:nvSpPr>
@@ -2602,7 +2662,7 @@
       </p:sp>
       <p:sp>
         <p:nvSpPr>
-          <p:cNvPr id="36" name="Text 34"/>
+          <p:cNvPr id="37" name="Text 35"/>
           <p:cNvSpPr txBox="1"/>
           <p:nvPr/>
         </p:nvSpPr>
@@ -2641,7 +2701,7 @@
       </p:sp>
       <p:sp>
         <p:nvSpPr>
-          <p:cNvPr id="37" name="Shape 35"/>
+          <p:cNvPr id="38" name="Shape 36"/>
           <p:cNvSpPr/>
           <p:nvPr/>
         </p:nvSpPr>
@@ -2668,7 +2728,7 @@
       </p:sp>
       <p:sp>
         <p:nvSpPr>
-          <p:cNvPr id="38" name="Text 36"/>
+          <p:cNvPr id="39" name="Text 37"/>
           <p:cNvSpPr txBox="1"/>
           <p:nvPr/>
         </p:nvSpPr>
@@ -2707,7 +2767,7 @@
       </p:sp>
       <p:sp>
         <p:nvSpPr>
-          <p:cNvPr id="39" name="Shape 37"/>
+          <p:cNvPr id="40" name="Shape 38"/>
           <p:cNvSpPr/>
           <p:nvPr/>
         </p:nvSpPr>
@@ -2734,7 +2794,7 @@
       </p:sp>
       <p:sp>
         <p:nvSpPr>
-          <p:cNvPr id="40" name="Text 38"/>
+          <p:cNvPr id="41" name="Text 39"/>
           <p:cNvSpPr txBox="1"/>
           <p:nvPr/>
         </p:nvSpPr>
@@ -2773,7 +2833,7 @@
       </p:sp>
       <p:sp>
         <p:nvSpPr>
-          <p:cNvPr id="41" name="Shape 39"/>
+          <p:cNvPr id="42" name="Shape 40"/>
           <p:cNvSpPr/>
           <p:nvPr/>
         </p:nvSpPr>
@@ -2796,7 +2856,7 @@
       </p:sp>
       <p:sp>
         <p:nvSpPr>
-          <p:cNvPr id="42" name="Text 40"/>
+          <p:cNvPr id="43" name="Text 41"/>
           <p:cNvSpPr txBox="1"/>
           <p:nvPr/>
         </p:nvSpPr>
@@ -2835,7 +2895,7 @@
       </p:sp>
       <p:sp>
         <p:nvSpPr>
-          <p:cNvPr id="43" name="Text 41"/>
+          <p:cNvPr id="44" name="Text 42"/>
           <p:cNvSpPr txBox="1"/>
           <p:nvPr/>
         </p:nvSpPr>
@@ -2874,7 +2934,7 @@
       </p:sp>
       <p:sp>
         <p:nvSpPr>
-          <p:cNvPr id="44" name="Text 42"/>
+          <p:cNvPr id="45" name="Text 43"/>
           <p:cNvSpPr txBox="1"/>
           <p:nvPr/>
         </p:nvSpPr>
@@ -2913,7 +2973,7 @@
       </p:sp>
       <p:sp>
         <p:nvSpPr>
-          <p:cNvPr id="45" name="Text 43"/>
+          <p:cNvPr id="46" name="Text 44"/>
           <p:cNvSpPr txBox="1"/>
           <p:nvPr/>
         </p:nvSpPr>
@@ -2952,14 +3012,14 @@
       </p:sp>
       <p:pic>
         <p:nvPicPr>
-          <p:cNvPr id="46" name="Image 0" descr="Örnhagen logo">    </p:cNvPr>
+          <p:cNvPr id="47" name="Image 0" descr="Örnhagen logo">    </p:cNvPr>
           <p:cNvPicPr>
             <a:picLocks noChangeAspect="1"/>
           </p:cNvPicPr>
           <p:nvPr/>
         </p:nvPicPr>
         <p:blipFill>
-          <a:blip r:embed="rId1"/>
+          <a:blip r:embed="rId2"/>
           <a:stretch>
             <a:fillRect/>
           </a:stretch>
@@ -15571,6 +15631,66 @@
         </p:nvSpPr>
         <p:spPr>
           <a:xfrm>
+            <a:off x="548640" y="6492240"/>
+            <a:ext cx="9592056" cy="320040"/>
+          </a:xfrm>
+          <a:prstGeom prst="rect">
+            <a:avLst/>
+          </a:prstGeom>
+          <a:noFill/>
+          <a:ln/>
+        </p:spPr>
+        <p:txBody>
+          <a:bodyPr wrap="square" lIns="0" tIns="0" rIns="0" bIns="0" rtlCol="0" anchor="t"/>
+          <a:lstStyle/>
+          <a:p>
+            <a:pPr indent="0" marL="0">
+              <a:buNone/>
+            </a:pPr>
+            <a:r>
+              <a:rPr lang="en-US" sz="1300" dirty="0">
+                <a:solidFill>
+                  <a:srgbClr val="1F2933"/>
+                </a:solidFill>
+                <a:latin typeface="Calibri" pitchFamily="34" charset="0"/>
+                <a:ea typeface="Calibri" pitchFamily="34" charset="-122"/>
+                <a:cs typeface="Calibri" pitchFamily="34" charset="-120"/>
+              </a:rPr>
+              <a:t>Documentation, latest versions and the PC monitor page: </a:t>
+            </a:r>
+            <a:pPr indent="0" marL="0">
+              <a:buNone/>
+            </a:pPr>
+            <a:r>
+              <a:rPr lang="en-US" sz="1300" b="1" u="sng" dirty="0">
+                <a:solidFill>
+                  <a:srgbClr val="184D7B"/>
+                </a:solidFill>
+                <a:latin typeface="Calibri" pitchFamily="34" charset="0"/>
+                <a:ea typeface="Calibri" pitchFamily="34" charset="-122"/>
+                <a:cs typeface="Calibri" pitchFamily="34" charset="-120"/>
+                <a:hlinkClick r:id="rId1" invalidUrl="" action="" tgtFrame="" tooltip="" history="1" highlightClick="0" endSnd="0">
+                  <a:extLst>
+                    <a:ext uri="{A12FA001-AC4F-418D-AE19-62706E023703}">
+                      <ahyp:hlinkClr xmlns:ahyp="http://schemas.microsoft.com/office/drawing/2018/hyperlinkcolor" val="tx"/>
+                    </a:ext>
+                  </a:extLst>
+                </a:hlinkClick>
+              </a:rPr>
+              <a:t>https://github.com/Teknosofen/EagleHagen</a:t>
+            </a:r>
+            <a:endParaRPr lang="en-US" sz="1300" dirty="0"/>
+          </a:p>
+        </p:txBody>
+      </p:sp>
+      <p:sp>
+        <p:nvSpPr>
+          <p:cNvPr id="37" name="Text 35"/>
+          <p:cNvSpPr txBox="1"/>
+          <p:nvPr/>
+        </p:nvSpPr>
+        <p:spPr>
+          <a:xfrm>
             <a:off x="1079504" y="7150608"/>
             <a:ext cx="1188720" cy="228600"/>
           </a:xfrm>
@@ -15604,14 +15724,14 @@
       </p:sp>
       <p:pic>
         <p:nvPicPr>
-          <p:cNvPr id="37" name="Image 0" descr="Örnhagen logo">    </p:cNvPr>
+          <p:cNvPr id="38" name="Image 0" descr="Örnhagen logo">    </p:cNvPr>
           <p:cNvPicPr>
             <a:picLocks noChangeAspect="1"/>
           </p:cNvPicPr>
           <p:nvPr/>
         </p:nvPicPr>
         <p:blipFill>
-          <a:blip r:embed="rId1"/>
+          <a:blip r:embed="rId2"/>
           <a:stretch>
             <a:fillRect/>
           </a:stretch>
@@ -15628,7 +15748,7 @@
       </p:pic>
       <p:sp>
         <p:nvSpPr>
-          <p:cNvPr id="38" name="Text 35"/>
+          <p:cNvPr id="39" name="Text 36"/>
           <p:cNvSpPr txBox="1"/>
           <p:nvPr/>
         </p:nvSpPr>
@@ -15667,7 +15787,7 @@
       </p:sp>
       <p:sp>
         <p:nvSpPr>
-          <p:cNvPr id="39" name="Text 36"/>
+          <p:cNvPr id="40" name="Text 37"/>
           <p:cNvSpPr txBox="1"/>
           <p:nvPr/>
         </p:nvSpPr>

</xml_diff>

<commit_message>
Reference photos and CAD in docs, use enclosure button names
- Design reference: new §2.7 (enclosure, photos, Fusion 360 model);
  pin table shows the button labels
- User guide: photo of the unit, links to both photos; buttons called
  "Restart pump" and "Select output" throughout, as labelled on the
  enclosure
- Handout: same button names on all pages; page 4 shows close-ups of
  the real labelled buttons
- README: list Images/ and Mech CAD/
- IMG_1770.jpg rotated upright

Co-Authored-By: Claude Opus 5.5 <noreply@anthropic.com>
</commit_message>
<xml_diff>
--- a/documentation/Eaglehagen_Basic_Setup.pptx
+++ b/documentation/Eaglehagen_Basic_Setup.pptx
@@ -4117,7 +4117,7 @@
                 <a:ea typeface="Calibri" pitchFamily="34" charset="-122"/>
                 <a:cs typeface="Calibri" pitchFamily="34" charset="-120"/>
               </a:rPr>
-              <a:t>if the PUMP badge is red, press the pump button (IO14) on the device, or tap Start Pump on the web page.</a:t>
+              <a:t>if the PUMP badge is red, press the Restart pump button on the device, or tap Start Pump on the web page.</a:t>
             </a:r>
             <a:endParaRPr lang="en-US" sz="1400" dirty="0"/>
           </a:p>
@@ -6610,7 +6610,7 @@
                 <a:ea typeface="Calibri" pitchFamily="34" charset="-122"/>
                 <a:cs typeface="Calibri" pitchFamily="34" charset="-120"/>
               </a:rPr>
-              <a:t>Two buttons on the board, three alarm badges on the screen and web page</a:t>
+              <a:t>Two labelled buttons next to the display, three alarm badges on the screen and web page</a:t>
             </a:r>
             <a:endParaRPr lang="en-US" sz="1500" dirty="0"/>
           </a:p>
@@ -6682,41 +6682,40 @@
           </a:ln>
         </p:spPr>
       </p:sp>
-      <p:sp>
-        <p:nvSpPr>
-          <p:cNvPr id="6" name="Shape 4"/>
-          <p:cNvSpPr/>
-          <p:nvPr/>
-        </p:nvSpPr>
-        <p:spPr>
-          <a:xfrm>
-            <a:off x="777240" y="2423160"/>
-            <a:ext cx="548640" cy="548640"/>
-          </a:xfrm>
-          <a:prstGeom prst="ellipse">
-            <a:avLst/>
-          </a:prstGeom>
-          <a:solidFill>
-            <a:srgbClr val="2B2F36"/>
-          </a:solidFill>
-          <a:ln w="38100">
-            <a:solidFill>
-              <a:srgbClr val="8A949E"/>
-            </a:solidFill>
-            <a:prstDash val="solid"/>
-          </a:ln>
-        </p:spPr>
-      </p:sp>
-      <p:sp>
-        <p:nvSpPr>
-          <p:cNvPr id="7" name="Text 5"/>
-          <p:cNvSpPr txBox="1"/>
-          <p:nvPr/>
-        </p:nvSpPr>
-        <p:spPr>
-          <a:xfrm>
-            <a:off x="1554480" y="2286000"/>
-            <a:ext cx="3017520" cy="365760"/>
+      <p:pic>
+        <p:nvPicPr>
+          <p:cNvPr id="6" name="Image 0" descr="Photo of the Restart pump button">    </p:cNvPr>
+          <p:cNvPicPr>
+            <a:picLocks noChangeAspect="1"/>
+          </p:cNvPicPr>
+          <p:nvPr/>
+        </p:nvPicPr>
+        <p:blipFill>
+          <a:blip r:embed="rId1"/>
+          <a:stretch>
+            <a:fillRect/>
+          </a:stretch>
+        </p:blipFill>
+        <p:spPr>
+          <a:xfrm>
+            <a:off x="731520" y="2368296"/>
+            <a:ext cx="941832" cy="658368"/>
+          </a:xfrm>
+          <a:prstGeom prst="rect">
+            <a:avLst/>
+          </a:prstGeom>
+        </p:spPr>
+      </p:pic>
+      <p:sp>
+        <p:nvSpPr>
+          <p:cNvPr id="7" name="Text 4"/>
+          <p:cNvSpPr txBox="1"/>
+          <p:nvPr/>
+        </p:nvSpPr>
+        <p:spPr>
+          <a:xfrm>
+            <a:off x="1874520" y="2286000"/>
+            <a:ext cx="2743200" cy="365760"/>
           </a:xfrm>
           <a:prstGeom prst="rect">
             <a:avLst/>
@@ -6740,7 +6739,7 @@
                 <a:ea typeface="Calibri" pitchFamily="34" charset="-122"/>
                 <a:cs typeface="Calibri" pitchFamily="34" charset="-120"/>
               </a:rPr>
-              <a:t>Pump button (IO14)</a:t>
+              <a:t>Restart pump</a:t>
             </a:r>
             <a:endParaRPr lang="en-US" sz="1600" dirty="0"/>
           </a:p>
@@ -6748,14 +6747,14 @@
       </p:sp>
       <p:sp>
         <p:nvSpPr>
-          <p:cNvPr id="8" name="Text 6"/>
-          <p:cNvSpPr txBox="1"/>
-          <p:nvPr/>
-        </p:nvSpPr>
-        <p:spPr>
-          <a:xfrm>
-            <a:off x="1554480" y="2651760"/>
-            <a:ext cx="3017520" cy="502920"/>
+          <p:cNvPr id="8" name="Text 5"/>
+          <p:cNvSpPr txBox="1"/>
+          <p:nvPr/>
+        </p:nvSpPr>
+        <p:spPr>
+          <a:xfrm>
+            <a:off x="1874520" y="2651760"/>
+            <a:ext cx="2743200" cy="502920"/>
           </a:xfrm>
           <a:prstGeom prst="rect">
             <a:avLst/>
@@ -6787,7 +6786,7 @@
       </p:sp>
       <p:sp>
         <p:nvSpPr>
-          <p:cNvPr id="9" name="Shape 7"/>
+          <p:cNvPr id="9" name="Shape 6"/>
           <p:cNvSpPr/>
           <p:nvPr/>
         </p:nvSpPr>
@@ -6812,41 +6811,40 @@
           </a:ln>
         </p:spPr>
       </p:sp>
-      <p:sp>
-        <p:nvSpPr>
-          <p:cNvPr id="10" name="Shape 8"/>
-          <p:cNvSpPr/>
-          <p:nvPr/>
-        </p:nvSpPr>
-        <p:spPr>
-          <a:xfrm>
-            <a:off x="777240" y="3703320"/>
-            <a:ext cx="548640" cy="548640"/>
-          </a:xfrm>
-          <a:prstGeom prst="ellipse">
-            <a:avLst/>
-          </a:prstGeom>
-          <a:solidFill>
-            <a:srgbClr val="2B2F36"/>
-          </a:solidFill>
-          <a:ln w="38100">
-            <a:solidFill>
-              <a:srgbClr val="8A949E"/>
-            </a:solidFill>
-            <a:prstDash val="solid"/>
-          </a:ln>
-        </p:spPr>
-      </p:sp>
-      <p:sp>
-        <p:nvSpPr>
-          <p:cNvPr id="11" name="Text 9"/>
-          <p:cNvSpPr txBox="1"/>
-          <p:nvPr/>
-        </p:nvSpPr>
-        <p:spPr>
-          <a:xfrm>
-            <a:off x="1554480" y="3566160"/>
-            <a:ext cx="3017520" cy="365760"/>
+      <p:pic>
+        <p:nvPicPr>
+          <p:cNvPr id="10" name="Image 1" descr="Photo of the Select output button">    </p:cNvPr>
+          <p:cNvPicPr>
+            <a:picLocks noChangeAspect="1"/>
+          </p:cNvPicPr>
+          <p:nvPr/>
+        </p:nvPicPr>
+        <p:blipFill>
+          <a:blip r:embed="rId2"/>
+          <a:stretch>
+            <a:fillRect/>
+          </a:stretch>
+        </p:blipFill>
+        <p:spPr>
+          <a:xfrm>
+            <a:off x="731520" y="3648456"/>
+            <a:ext cx="941832" cy="658368"/>
+          </a:xfrm>
+          <a:prstGeom prst="rect">
+            <a:avLst/>
+          </a:prstGeom>
+        </p:spPr>
+      </p:pic>
+      <p:sp>
+        <p:nvSpPr>
+          <p:cNvPr id="11" name="Text 7"/>
+          <p:cNvSpPr txBox="1"/>
+          <p:nvPr/>
+        </p:nvSpPr>
+        <p:spPr>
+          <a:xfrm>
+            <a:off x="1874520" y="3566160"/>
+            <a:ext cx="2743200" cy="365760"/>
           </a:xfrm>
           <a:prstGeom prst="rect">
             <a:avLst/>
@@ -6870,7 +6868,7 @@
                 <a:ea typeface="Calibri" pitchFamily="34" charset="-122"/>
                 <a:cs typeface="Calibri" pitchFamily="34" charset="-120"/>
               </a:rPr>
-              <a:t>BOOT button</a:t>
+              <a:t>Select output</a:t>
             </a:r>
             <a:endParaRPr lang="en-US" sz="1600" dirty="0"/>
           </a:p>
@@ -6878,14 +6876,14 @@
       </p:sp>
       <p:sp>
         <p:nvSpPr>
-          <p:cNvPr id="12" name="Text 10"/>
-          <p:cNvSpPr txBox="1"/>
-          <p:nvPr/>
-        </p:nvSpPr>
-        <p:spPr>
-          <a:xfrm>
-            <a:off x="1554480" y="3931920"/>
-            <a:ext cx="3017520" cy="502920"/>
+          <p:cNvPr id="12" name="Text 8"/>
+          <p:cNvSpPr txBox="1"/>
+          <p:nvPr/>
+        </p:nvSpPr>
+        <p:spPr>
+          <a:xfrm>
+            <a:off x="1874520" y="3931920"/>
+            <a:ext cx="2743200" cy="502920"/>
           </a:xfrm>
           <a:prstGeom prst="rect">
             <a:avLst/>
@@ -6917,7 +6915,7 @@
       </p:sp>
       <p:sp>
         <p:nvSpPr>
-          <p:cNvPr id="13" name="Shape 11"/>
+          <p:cNvPr id="13" name="Shape 9"/>
           <p:cNvSpPr/>
           <p:nvPr/>
         </p:nvSpPr>
@@ -6944,7 +6942,7 @@
       </p:sp>
       <p:sp>
         <p:nvSpPr>
-          <p:cNvPr id="14" name="Text 12"/>
+          <p:cNvPr id="14" name="Text 10"/>
           <p:cNvSpPr txBox="1"/>
           <p:nvPr/>
         </p:nvSpPr>
@@ -6989,7 +6987,7 @@
                 <a:ea typeface="Calibri" pitchFamily="34" charset="-122"/>
                 <a:cs typeface="Calibri" pitchFamily="34" charset="-120"/>
               </a:rPr>
-              <a:t>do not hold BOOT while switching the device on. It then starts in programming mode and the monitor will not run. Just switch off and on again.</a:t>
+              <a:t>do not hold Select output while switching the device on. It then starts in programming mode and the monitor will not run. Just switch off and on again.</a:t>
             </a:r>
             <a:endParaRPr lang="en-US" sz="1300" dirty="0"/>
           </a:p>
@@ -6997,7 +6995,7 @@
       </p:sp>
       <p:sp>
         <p:nvSpPr>
-          <p:cNvPr id="15" name="Text 13"/>
+          <p:cNvPr id="15" name="Text 11"/>
           <p:cNvSpPr txBox="1"/>
           <p:nvPr/>
         </p:nvSpPr>
@@ -7036,7 +7034,7 @@
       </p:sp>
       <p:sp>
         <p:nvSpPr>
-          <p:cNvPr id="16" name="Shape 14"/>
+          <p:cNvPr id="16" name="Shape 12"/>
           <p:cNvSpPr/>
           <p:nvPr/>
         </p:nvSpPr>
@@ -7063,7 +7061,7 @@
       </p:sp>
       <p:sp>
         <p:nvSpPr>
-          <p:cNvPr id="17" name="Shape 15"/>
+          <p:cNvPr id="17" name="Shape 13"/>
           <p:cNvSpPr/>
           <p:nvPr/>
         </p:nvSpPr>
@@ -7090,7 +7088,7 @@
       </p:sp>
       <p:sp>
         <p:nvSpPr>
-          <p:cNvPr id="18" name="Text 16"/>
+          <p:cNvPr id="18" name="Text 14"/>
           <p:cNvSpPr txBox="1"/>
           <p:nvPr/>
         </p:nvSpPr>
@@ -7129,7 +7127,7 @@
       </p:sp>
       <p:sp>
         <p:nvSpPr>
-          <p:cNvPr id="19" name="Text 17"/>
+          <p:cNvPr id="19" name="Text 15"/>
           <p:cNvSpPr txBox="1"/>
           <p:nvPr/>
         </p:nvSpPr>
@@ -7168,7 +7166,7 @@
       </p:sp>
       <p:sp>
         <p:nvSpPr>
-          <p:cNvPr id="20" name="Text 18"/>
+          <p:cNvPr id="20" name="Text 16"/>
           <p:cNvSpPr txBox="1"/>
           <p:nvPr/>
         </p:nvSpPr>
@@ -7199,7 +7197,7 @@
                 <a:ea typeface="Calibri" pitchFamily="34" charset="-122"/>
                 <a:cs typeface="Calibri" pitchFamily="34" charset="-120"/>
               </a:rPr>
-              <a:t>Press the pump button or Start Pump on the web page.</a:t>
+              <a:t>Press Restart pump on the device or Start Pump on the web page.</a:t>
             </a:r>
             <a:endParaRPr lang="en-US" sz="1300" dirty="0"/>
           </a:p>
@@ -7207,7 +7205,7 @@
       </p:sp>
       <p:sp>
         <p:nvSpPr>
-          <p:cNvPr id="21" name="Shape 19"/>
+          <p:cNvPr id="21" name="Shape 17"/>
           <p:cNvSpPr/>
           <p:nvPr/>
         </p:nvSpPr>
@@ -7234,7 +7232,7 @@
       </p:sp>
       <p:sp>
         <p:nvSpPr>
-          <p:cNvPr id="22" name="Shape 20"/>
+          <p:cNvPr id="22" name="Shape 18"/>
           <p:cNvSpPr/>
           <p:nvPr/>
         </p:nvSpPr>
@@ -7261,7 +7259,7 @@
       </p:sp>
       <p:sp>
         <p:nvSpPr>
-          <p:cNvPr id="23" name="Text 21"/>
+          <p:cNvPr id="23" name="Text 19"/>
           <p:cNvSpPr txBox="1"/>
           <p:nvPr/>
         </p:nvSpPr>
@@ -7300,7 +7298,7 @@
       </p:sp>
       <p:sp>
         <p:nvSpPr>
-          <p:cNvPr id="24" name="Text 22"/>
+          <p:cNvPr id="24" name="Text 20"/>
           <p:cNvSpPr txBox="1"/>
           <p:nvPr/>
         </p:nvSpPr>
@@ -7339,7 +7337,7 @@
       </p:sp>
       <p:sp>
         <p:nvSpPr>
-          <p:cNvPr id="25" name="Text 23"/>
+          <p:cNvPr id="25" name="Text 21"/>
           <p:cNvSpPr txBox="1"/>
           <p:nvPr/>
         </p:nvSpPr>
@@ -7378,7 +7376,7 @@
       </p:sp>
       <p:sp>
         <p:nvSpPr>
-          <p:cNvPr id="26" name="Shape 24"/>
+          <p:cNvPr id="26" name="Shape 22"/>
           <p:cNvSpPr/>
           <p:nvPr/>
         </p:nvSpPr>
@@ -7405,7 +7403,7 @@
       </p:sp>
       <p:sp>
         <p:nvSpPr>
-          <p:cNvPr id="27" name="Shape 25"/>
+          <p:cNvPr id="27" name="Shape 23"/>
           <p:cNvSpPr/>
           <p:nvPr/>
         </p:nvSpPr>
@@ -7432,7 +7430,7 @@
       </p:sp>
       <p:sp>
         <p:nvSpPr>
-          <p:cNvPr id="28" name="Text 26"/>
+          <p:cNvPr id="28" name="Text 24"/>
           <p:cNvSpPr txBox="1"/>
           <p:nvPr/>
         </p:nvSpPr>
@@ -7471,7 +7469,7 @@
       </p:sp>
       <p:sp>
         <p:nvSpPr>
-          <p:cNvPr id="29" name="Text 27"/>
+          <p:cNvPr id="29" name="Text 25"/>
           <p:cNvSpPr txBox="1"/>
           <p:nvPr/>
         </p:nvSpPr>
@@ -7510,7 +7508,7 @@
       </p:sp>
       <p:sp>
         <p:nvSpPr>
-          <p:cNvPr id="30" name="Text 28"/>
+          <p:cNvPr id="30" name="Text 26"/>
           <p:cNvSpPr txBox="1"/>
           <p:nvPr/>
         </p:nvSpPr>
@@ -7549,7 +7547,7 @@
       </p:sp>
       <p:sp>
         <p:nvSpPr>
-          <p:cNvPr id="31" name="Text 29"/>
+          <p:cNvPr id="31" name="Text 27"/>
           <p:cNvSpPr txBox="1"/>
           <p:nvPr/>
         </p:nvSpPr>
@@ -7602,7 +7600,7 @@
       </p:sp>
       <p:sp>
         <p:nvSpPr>
-          <p:cNvPr id="32" name="Text 30"/>
+          <p:cNvPr id="32" name="Text 28"/>
           <p:cNvSpPr txBox="1"/>
           <p:nvPr/>
         </p:nvSpPr>
@@ -7641,14 +7639,14 @@
       </p:sp>
       <p:pic>
         <p:nvPicPr>
-          <p:cNvPr id="33" name="Image 0" descr="Örnhagen logo">    </p:cNvPr>
+          <p:cNvPr id="33" name="Image 2" descr="Örnhagen logo">    </p:cNvPr>
           <p:cNvPicPr>
             <a:picLocks noChangeAspect="1"/>
           </p:cNvPicPr>
           <p:nvPr/>
         </p:nvPicPr>
         <p:blipFill>
-          <a:blip r:embed="rId1"/>
+          <a:blip r:embed="rId3"/>
           <a:stretch>
             <a:fillRect/>
           </a:stretch>
@@ -7665,7 +7663,7 @@
       </p:pic>
       <p:sp>
         <p:nvSpPr>
-          <p:cNvPr id="34" name="Text 31"/>
+          <p:cNvPr id="34" name="Text 29"/>
           <p:cNvSpPr txBox="1"/>
           <p:nvPr/>
         </p:nvSpPr>
@@ -7704,7 +7702,7 @@
       </p:sp>
       <p:sp>
         <p:nvSpPr>
-          <p:cNvPr id="35" name="Text 32"/>
+          <p:cNvPr id="35" name="Text 30"/>
           <p:cNvSpPr txBox="1"/>
           <p:nvPr/>
         </p:nvSpPr>
@@ -11249,7 +11247,7 @@
                 <a:ea typeface="Calibri" pitchFamily="34" charset="-122"/>
                 <a:cs typeface="Calibri" pitchFamily="34" charset="-120"/>
               </a:rPr>
-              <a:t>Check that the screen shows “Out: LabVIEW”. If it shows “Out: ASCII”, press the BOOT button once.</a:t>
+              <a:t>Check that the screen shows “Out: LabVIEW”. If it shows “Out: ASCII”, press the Select output button once.</a:t>
             </a:r>
             <a:endParaRPr lang="en-US" sz="1400" dirty="0"/>
           </a:p>
@@ -11946,7 +11944,7 @@
                 <a:ea typeface="Calibri" pitchFamily="34" charset="-122"/>
                 <a:cs typeface="Calibri" pitchFamily="34" charset="-120"/>
               </a:rPr>
-              <a:t>LabVIEW and ASCII are detected automatically, even if BOOT is pressed while connected.</a:t>
+              <a:t>LabVIEW and ASCII are detected automatically, even if Select output is pressed while connected.</a:t>
             </a:r>
             <a:endParaRPr lang="en-US" sz="1300" dirty="0"/>
           </a:p>
@@ -14819,7 +14817,7 @@
                 <a:ea typeface="Calibri" pitchFamily="34" charset="-122"/>
                 <a:cs typeface="Calibri" pitchFamily="34" charset="-120"/>
               </a:rPr>
-              <a:t>Pump button</a:t>
+              <a:t>Button</a:t>
             </a:r>
             <a:endParaRPr lang="en-US" sz="1300" dirty="0"/>
           </a:p>
@@ -14850,7 +14848,7 @@
               <a:buNone/>
             </a:pPr>
             <a:r>
-              <a:rPr lang="en-US" sz="2400" b="1" dirty="0">
+              <a:rPr lang="en-US" sz="2000" b="1" dirty="0">
                 <a:solidFill>
                   <a:srgbClr val="184D7B"/>
                 </a:solidFill>
@@ -14858,9 +14856,9 @@
                 <a:ea typeface="Cambria" pitchFamily="34" charset="-122"/>
                 <a:cs typeface="Cambria" pitchFamily="34" charset="-120"/>
               </a:rPr>
-              <a:t>IO14</a:t>
-            </a:r>
-            <a:endParaRPr lang="en-US" sz="2400" dirty="0"/>
+              <a:t>Restart pump</a:t>
+            </a:r>
+            <a:endParaRPr lang="en-US" sz="2000" dirty="0"/>
           </a:p>
         </p:txBody>
       </p:sp>
@@ -14963,7 +14961,7 @@
                 <a:ea typeface="Calibri" pitchFamily="34" charset="-122"/>
                 <a:cs typeface="Calibri" pitchFamily="34" charset="-120"/>
               </a:rPr>
-              <a:t>BOOT button</a:t>
+              <a:t>Button</a:t>
             </a:r>
             <a:endParaRPr lang="en-US" sz="1300" dirty="0"/>
           </a:p>
@@ -15002,7 +15000,7 @@
                 <a:ea typeface="Cambria" pitchFamily="34" charset="-122"/>
                 <a:cs typeface="Cambria" pitchFamily="34" charset="-120"/>
               </a:rPr>
-              <a:t>LabVIEW ⇄ ASCII</a:t>
+              <a:t>Select output</a:t>
             </a:r>
             <a:endParaRPr lang="en-US" sz="1800" dirty="0"/>
           </a:p>
@@ -15041,7 +15039,7 @@
                 <a:ea typeface="Calibri" pitchFamily="34" charset="-122"/>
                 <a:cs typeface="Calibri" pitchFamily="34" charset="-120"/>
               </a:rPr>
-              <a:t>USB output format</a:t>
+              <a:t>USB format LabVIEW ⇄ ASCII</a:t>
             </a:r>
             <a:endParaRPr lang="en-US" sz="1200" dirty="0"/>
           </a:p>

</xml_diff>